<commit_message>
PPT: ajout slide Cas d'usage (slide 10)
4 cas d'usage en grille 2x2 : gagner du temps, maîtriser les coûts de l'IA,
reprendre le legacy en main, superviser les ways of working.
Slides suivantes renumérotées (14 slides au total).

Co-Authored-By: Claude Opus 4.8 <noreply@anthropic.com>
</commit_message>
<xml_diff>
--- a/public/reference/lyriks-template.pptx
+++ b/public/reference/lyriks-template.pptx
@@ -18,9 +18,10 @@
     <p:sldId id="266" r:id="rId12"/>
     <p:sldId id="267" r:id="rId13"/>
     <p:sldId id="268" r:id="rId14"/>
+    <p:sldId id="269" r:id="rId15"/>
   </p:sldIdLst>
   <p:notesMasterIdLst>
-    <p:notesMasterId r:id="rId15"/>
+    <p:notesMasterId r:id="rId16"/>
   </p:notesMasterIdLst>
   <p:sldSz cx="12191695" cy="6858000"/>
   <p:notesSz cx="6858000" cy="12191695"/>
@@ -890,6 +891,94 @@
             <a:fld id="{F7021451-1387-4CA6-816F-3879F97B5CBC}" type="slidenum">
               <a:rPr lang="en-US"/>
               <a:t>13</a:t>
+            </a:fld>
+            <a:endParaRPr lang="en-US"/>
+          </a:p>
+        </p:txBody>
+      </p:sp>
+    </p:spTree>
+    <p:extLst>
+      <p:ext uri="{BB962C8B-B14F-4D97-AF65-F5344CB8AC3E}">
+        <p14:creationId xmlns:p14="http://schemas.microsoft.com/office/powerpoint/2010/main" val="1024086991"/>
+      </p:ext>
+    </p:extLst>
+  </p:cSld>
+  <p:clrMapOvr>
+    <a:masterClrMapping/>
+  </p:clrMapOvr>
+</p:notes>
+</file>
+
+<file path=ppt/notesSlides/notesSlide14.xml><?xml version="1.0" encoding="utf-8"?>
+<p:notes xmlns:a="http://schemas.openxmlformats.org/drawingml/2006/main" xmlns:r="http://schemas.openxmlformats.org/officeDocument/2006/relationships" xmlns:p="http://schemas.openxmlformats.org/presentationml/2006/main">
+  <p:cSld>
+    <p:spTree>
+      <p:nvGrpSpPr>
+        <p:cNvPr id="1" name=""/>
+        <p:cNvGrpSpPr/>
+        <p:nvPr/>
+      </p:nvGrpSpPr>
+      <p:grpSpPr>
+        <a:xfrm>
+          <a:off x="0" y="0"/>
+          <a:ext cx="0" cy="0"/>
+          <a:chOff x="0" y="0"/>
+          <a:chExt cx="0" cy="0"/>
+        </a:xfrm>
+      </p:grpSpPr>
+      <p:sp>
+        <p:nvSpPr>
+          <p:cNvPr id="2" name="Slide Image Placeholder 1"/>
+          <p:cNvSpPr>
+            <a:spLocks noGrp="1" noRot="1" noChangeAspect="1"/>
+          </p:cNvSpPr>
+          <p:nvPr>
+            <p:ph type="sldImg"/>
+          </p:nvPr>
+        </p:nvSpPr>
+        <p:spPr/>
+      </p:sp>
+      <p:sp>
+        <p:nvSpPr>
+          <p:cNvPr id="3" name="Notes Placeholder 2"/>
+          <p:cNvSpPr>
+            <a:spLocks noGrp="1"/>
+          </p:cNvSpPr>
+          <p:nvPr>
+            <p:ph type="body" idx="1"/>
+          </p:nvPr>
+        </p:nvSpPr>
+        <p:spPr/>
+        <p:txBody>
+          <a:bodyPr/>
+          <a:lstStyle/>
+          <a:p>
+            <a:r>
+              <a:rPr lang="en-US" dirty="0"/>
+              <a:t/>
+            </a:r>
+            <a:endParaRPr lang="en-US" dirty="0"/>
+          </a:p>
+        </p:txBody>
+      </p:sp>
+      <p:sp>
+        <p:nvSpPr>
+          <p:cNvPr id="4" name="Slide Number Placeholder 3"/>
+          <p:cNvSpPr>
+            <a:spLocks noGrp="1"/>
+          </p:cNvSpPr>
+          <p:nvPr>
+            <p:ph type="sldNum" sz="quarter" idx="10"/>
+          </p:nvPr>
+        </p:nvSpPr>
+        <p:spPr/>
+        <p:txBody>
+          <a:bodyPr/>
+          <a:lstStyle/>
+          <a:p>
+            <a:fld id="{F7021451-1387-4CA6-816F-3879F97B5CBC}" type="slidenum">
+              <a:rPr lang="en-US"/>
+              <a:t>14</a:t>
             </a:fld>
             <a:endParaRPr lang="en-US"/>
           </a:p>
@@ -2352,6 +2441,859 @@
     <p:bg>
       <p:bgPr>
         <a:solidFill>
+          <a:srgbClr val="FFFFFF"/>
+        </a:solidFill>
+      </p:bgPr>
+    </p:bg>
+    <p:spTree>
+      <p:nvGrpSpPr>
+        <p:cNvPr id="1" name=""/>
+        <p:cNvGrpSpPr/>
+        <p:nvPr/>
+      </p:nvGrpSpPr>
+      <p:grpSpPr>
+        <a:xfrm>
+          <a:off x="0" y="0"/>
+          <a:ext cx="0" cy="0"/>
+          <a:chOff x="0" y="0"/>
+          <a:chExt cx="0" cy="0"/>
+        </a:xfrm>
+      </p:grpSpPr>
+      <p:sp>
+        <p:nvSpPr>
+          <p:cNvPr id="2" name="Text 0"/>
+          <p:cNvSpPr/>
+          <p:nvPr/>
+        </p:nvSpPr>
+        <p:spPr>
+          <a:xfrm>
+            <a:off x="640080" y="640080"/>
+            <a:ext cx="8229600" cy="274320"/>
+          </a:xfrm>
+          <a:prstGeom prst="rect">
+            <a:avLst/>
+          </a:prstGeom>
+          <a:noFill/>
+          <a:ln/>
+        </p:spPr>
+        <p:txBody>
+          <a:bodyPr wrap="square" lIns="0" tIns="0" rIns="0" bIns="0" rtlCol="0" anchor="ctr"/>
+          <a:lstStyle/>
+          <a:p>
+            <a:pPr indent="0" marL="0">
+              <a:buNone/>
+            </a:pPr>
+            <a:r>
+              <a:rPr lang="en-US" sz="1100" b="1" spc="250" kern="0" dirty="0">
+                <a:solidFill>
+                  <a:srgbClr val="FFA101"/>
+                </a:solidFill>
+                <a:latin typeface="JetBrains Mono" pitchFamily="34" charset="0"/>
+                <a:ea typeface="JetBrains Mono" pitchFamily="34" charset="-122"/>
+                <a:cs typeface="JetBrains Mono" pitchFamily="34" charset="-120"/>
+              </a:rPr>
+              <a:t>CAS D'USAGE</a:t>
+            </a:r>
+            <a:endParaRPr lang="en-US" sz="1100" dirty="0"/>
+          </a:p>
+        </p:txBody>
+      </p:sp>
+      <p:sp>
+        <p:nvSpPr>
+          <p:cNvPr id="3" name="Text 1"/>
+          <p:cNvSpPr/>
+          <p:nvPr/>
+        </p:nvSpPr>
+        <p:spPr>
+          <a:xfrm>
+            <a:off x="640080" y="960120"/>
+            <a:ext cx="10058400" cy="822960"/>
+          </a:xfrm>
+          <a:prstGeom prst="rect">
+            <a:avLst/>
+          </a:prstGeom>
+          <a:noFill/>
+          <a:ln/>
+        </p:spPr>
+        <p:txBody>
+          <a:bodyPr wrap="square" lIns="0" tIns="0" rIns="0" bIns="0" rtlCol="0" anchor="ctr"/>
+          <a:lstStyle/>
+          <a:p>
+            <a:pPr indent="0" marL="0">
+              <a:buNone/>
+            </a:pPr>
+            <a:r>
+              <a:rPr lang="en-US" sz="3000" b="1" dirty="0">
+                <a:solidFill>
+                  <a:srgbClr val="0A0A0A"/>
+                </a:solidFill>
+                <a:latin typeface="Space Grotesk" pitchFamily="34" charset="0"/>
+                <a:ea typeface="Space Grotesk" pitchFamily="34" charset="-122"/>
+                <a:cs typeface="Space Grotesk" pitchFamily="34" charset="-120"/>
+              </a:rPr>
+              <a:t>Ce que Lyriks débloque</a:t>
+            </a:r>
+            <a:endParaRPr lang="en-US" sz="3000" dirty="0"/>
+          </a:p>
+        </p:txBody>
+      </p:sp>
+      <p:sp>
+        <p:nvSpPr>
+          <p:cNvPr id="4" name="Shape 2"/>
+          <p:cNvSpPr/>
+          <p:nvPr/>
+        </p:nvSpPr>
+        <p:spPr>
+          <a:xfrm>
+            <a:off x="640080" y="2011680"/>
+            <a:ext cx="5276088" cy="1691640"/>
+          </a:xfrm>
+          <a:prstGeom prst="roundRect">
+            <a:avLst>
+              <a:gd name="adj" fmla="val 5405"/>
+            </a:avLst>
+          </a:prstGeom>
+          <a:solidFill>
+            <a:srgbClr val="FFFFFF"/>
+          </a:solidFill>
+          <a:ln w="12700">
+            <a:solidFill>
+              <a:srgbClr val="E8E8EE"/>
+            </a:solidFill>
+            <a:prstDash val="solid"/>
+          </a:ln>
+          <a:effectLst>
+            <a:outerShdw sx="100000" sy="100000" kx="0" ky="0" algn="bl" rotWithShape="0" blurRad="114300" dist="38100" dir="5400000">
+              <a:srgbClr val="10122A">
+                <a:alpha val="12000"/>
+              </a:srgbClr>
+            </a:outerShdw>
+          </a:effectLst>
+        </p:spPr>
+      </p:sp>
+      <p:sp>
+        <p:nvSpPr>
+          <p:cNvPr id="5" name="Shape 3"/>
+          <p:cNvSpPr/>
+          <p:nvPr/>
+        </p:nvSpPr>
+        <p:spPr>
+          <a:xfrm>
+            <a:off x="960120" y="2331720"/>
+            <a:ext cx="457200" cy="457200"/>
+          </a:xfrm>
+          <a:prstGeom prst="roundRect">
+            <a:avLst>
+              <a:gd name="adj" fmla="val 16000"/>
+            </a:avLst>
+          </a:prstGeom>
+          <a:solidFill>
+            <a:srgbClr val="0066FF"/>
+          </a:solidFill>
+          <a:ln/>
+        </p:spPr>
+      </p:sp>
+      <p:sp>
+        <p:nvSpPr>
+          <p:cNvPr id="6" name="Text 4"/>
+          <p:cNvSpPr/>
+          <p:nvPr/>
+        </p:nvSpPr>
+        <p:spPr>
+          <a:xfrm>
+            <a:off x="960120" y="2331720"/>
+            <a:ext cx="457200" cy="457200"/>
+          </a:xfrm>
+          <a:prstGeom prst="rect">
+            <a:avLst/>
+          </a:prstGeom>
+          <a:noFill/>
+          <a:ln/>
+        </p:spPr>
+        <p:txBody>
+          <a:bodyPr wrap="square" lIns="0" tIns="0" rIns="0" bIns="0" rtlCol="0" anchor="ctr"/>
+          <a:lstStyle/>
+          <a:p>
+            <a:pPr algn="ctr" indent="0" marL="0">
+              <a:buNone/>
+            </a:pPr>
+            <a:r>
+              <a:rPr lang="en-US" sz="1300" b="1" dirty="0">
+                <a:solidFill>
+                  <a:srgbClr val="FFFFFF"/>
+                </a:solidFill>
+                <a:latin typeface="JetBrains Mono" pitchFamily="34" charset="0"/>
+                <a:ea typeface="JetBrains Mono" pitchFamily="34" charset="-122"/>
+                <a:cs typeface="JetBrains Mono" pitchFamily="34" charset="-120"/>
+              </a:rPr>
+              <a:t>1</a:t>
+            </a:r>
+            <a:endParaRPr lang="en-US" sz="1300" dirty="0"/>
+          </a:p>
+        </p:txBody>
+      </p:sp>
+      <p:sp>
+        <p:nvSpPr>
+          <p:cNvPr id="7" name="Text 5"/>
+          <p:cNvSpPr/>
+          <p:nvPr/>
+        </p:nvSpPr>
+        <p:spPr>
+          <a:xfrm>
+            <a:off x="1600200" y="2304288"/>
+            <a:ext cx="4023360" cy="548640"/>
+          </a:xfrm>
+          <a:prstGeom prst="rect">
+            <a:avLst/>
+          </a:prstGeom>
+          <a:noFill/>
+          <a:ln/>
+        </p:spPr>
+        <p:txBody>
+          <a:bodyPr wrap="square" lIns="0" tIns="0" rIns="0" bIns="0" rtlCol="0" anchor="ctr"/>
+          <a:lstStyle/>
+          <a:p>
+            <a:pPr indent="0" marL="0">
+              <a:buNone/>
+            </a:pPr>
+            <a:r>
+              <a:rPr lang="en-US" sz="1700" b="1" dirty="0">
+                <a:solidFill>
+                  <a:srgbClr val="0A0A0A"/>
+                </a:solidFill>
+                <a:latin typeface="Space Grotesk" pitchFamily="34" charset="0"/>
+                <a:ea typeface="Space Grotesk" pitchFamily="34" charset="-122"/>
+                <a:cs typeface="Space Grotesk" pitchFamily="34" charset="-120"/>
+              </a:rPr>
+              <a:t>Gagner du temps</a:t>
+            </a:r>
+            <a:endParaRPr lang="en-US" sz="1700" dirty="0"/>
+          </a:p>
+        </p:txBody>
+      </p:sp>
+      <p:sp>
+        <p:nvSpPr>
+          <p:cNvPr id="8" name="Text 6"/>
+          <p:cNvSpPr/>
+          <p:nvPr/>
+        </p:nvSpPr>
+        <p:spPr>
+          <a:xfrm>
+            <a:off x="960120" y="2926080"/>
+            <a:ext cx="4663440" cy="685800"/>
+          </a:xfrm>
+          <a:prstGeom prst="rect">
+            <a:avLst/>
+          </a:prstGeom>
+          <a:noFill/>
+          <a:ln/>
+        </p:spPr>
+        <p:txBody>
+          <a:bodyPr wrap="square" lIns="0" tIns="0" rIns="0" bIns="0" rtlCol="0" anchor="ctr"/>
+          <a:lstStyle/>
+          <a:p>
+            <a:pPr indent="0" marL="0">
+              <a:lnSpc>
+                <a:spcPct val="115000"/>
+              </a:lnSpc>
+              <a:buNone/>
+            </a:pPr>
+            <a:r>
+              <a:rPr lang="en-US" sz="1300" dirty="0">
+                <a:solidFill>
+                  <a:srgbClr val="535462"/>
+                </a:solidFill>
+                <a:latin typeface="Montserrat" pitchFamily="34" charset="0"/>
+                <a:ea typeface="Montserrat" pitchFamily="34" charset="-122"/>
+                <a:cs typeface="Montserrat" pitchFamily="34" charset="-120"/>
+              </a:rPr>
+              <a:t>Des specs claires et réutilisables : moins de rework, moins d'allers-retours, des délais tenus.</a:t>
+            </a:r>
+            <a:endParaRPr lang="en-US" sz="1300" dirty="0"/>
+          </a:p>
+        </p:txBody>
+      </p:sp>
+      <p:sp>
+        <p:nvSpPr>
+          <p:cNvPr id="9" name="Shape 7"/>
+          <p:cNvSpPr/>
+          <p:nvPr/>
+        </p:nvSpPr>
+        <p:spPr>
+          <a:xfrm>
+            <a:off x="6272784" y="2011680"/>
+            <a:ext cx="5276088" cy="1691640"/>
+          </a:xfrm>
+          <a:prstGeom prst="roundRect">
+            <a:avLst>
+              <a:gd name="adj" fmla="val 5405"/>
+            </a:avLst>
+          </a:prstGeom>
+          <a:solidFill>
+            <a:srgbClr val="FFFFFF"/>
+          </a:solidFill>
+          <a:ln w="12700">
+            <a:solidFill>
+              <a:srgbClr val="E8E8EE"/>
+            </a:solidFill>
+            <a:prstDash val="solid"/>
+          </a:ln>
+          <a:effectLst>
+            <a:outerShdw sx="100000" sy="100000" kx="0" ky="0" algn="bl" rotWithShape="0" blurRad="114300" dist="38100" dir="5400000">
+              <a:srgbClr val="10122A">
+                <a:alpha val="12000"/>
+              </a:srgbClr>
+            </a:outerShdw>
+          </a:effectLst>
+        </p:spPr>
+      </p:sp>
+      <p:sp>
+        <p:nvSpPr>
+          <p:cNvPr id="10" name="Shape 8"/>
+          <p:cNvSpPr/>
+          <p:nvPr/>
+        </p:nvSpPr>
+        <p:spPr>
+          <a:xfrm>
+            <a:off x="6592824" y="2331720"/>
+            <a:ext cx="457200" cy="457200"/>
+          </a:xfrm>
+          <a:prstGeom prst="roundRect">
+            <a:avLst>
+              <a:gd name="adj" fmla="val 16000"/>
+            </a:avLst>
+          </a:prstGeom>
+          <a:solidFill>
+            <a:srgbClr val="FFA101"/>
+          </a:solidFill>
+          <a:ln/>
+        </p:spPr>
+      </p:sp>
+      <p:sp>
+        <p:nvSpPr>
+          <p:cNvPr id="11" name="Text 9"/>
+          <p:cNvSpPr/>
+          <p:nvPr/>
+        </p:nvSpPr>
+        <p:spPr>
+          <a:xfrm>
+            <a:off x="6592824" y="2331720"/>
+            <a:ext cx="457200" cy="457200"/>
+          </a:xfrm>
+          <a:prstGeom prst="rect">
+            <a:avLst/>
+          </a:prstGeom>
+          <a:noFill/>
+          <a:ln/>
+        </p:spPr>
+        <p:txBody>
+          <a:bodyPr wrap="square" lIns="0" tIns="0" rIns="0" bIns="0" rtlCol="0" anchor="ctr"/>
+          <a:lstStyle/>
+          <a:p>
+            <a:pPr algn="ctr" indent="0" marL="0">
+              <a:buNone/>
+            </a:pPr>
+            <a:r>
+              <a:rPr lang="en-US" sz="1300" b="1" dirty="0">
+                <a:solidFill>
+                  <a:srgbClr val="FFFFFF"/>
+                </a:solidFill>
+                <a:latin typeface="JetBrains Mono" pitchFamily="34" charset="0"/>
+                <a:ea typeface="JetBrains Mono" pitchFamily="34" charset="-122"/>
+                <a:cs typeface="JetBrains Mono" pitchFamily="34" charset="-120"/>
+              </a:rPr>
+              <a:t>2</a:t>
+            </a:r>
+            <a:endParaRPr lang="en-US" sz="1300" dirty="0"/>
+          </a:p>
+        </p:txBody>
+      </p:sp>
+      <p:sp>
+        <p:nvSpPr>
+          <p:cNvPr id="12" name="Text 10"/>
+          <p:cNvSpPr/>
+          <p:nvPr/>
+        </p:nvSpPr>
+        <p:spPr>
+          <a:xfrm>
+            <a:off x="7232904" y="2304288"/>
+            <a:ext cx="4023360" cy="548640"/>
+          </a:xfrm>
+          <a:prstGeom prst="rect">
+            <a:avLst/>
+          </a:prstGeom>
+          <a:noFill/>
+          <a:ln/>
+        </p:spPr>
+        <p:txBody>
+          <a:bodyPr wrap="square" lIns="0" tIns="0" rIns="0" bIns="0" rtlCol="0" anchor="ctr"/>
+          <a:lstStyle/>
+          <a:p>
+            <a:pPr indent="0" marL="0">
+              <a:buNone/>
+            </a:pPr>
+            <a:r>
+              <a:rPr lang="en-US" sz="1700" b="1" dirty="0">
+                <a:solidFill>
+                  <a:srgbClr val="0A0A0A"/>
+                </a:solidFill>
+                <a:latin typeface="Space Grotesk" pitchFamily="34" charset="0"/>
+                <a:ea typeface="Space Grotesk" pitchFamily="34" charset="-122"/>
+                <a:cs typeface="Space Grotesk" pitchFamily="34" charset="-120"/>
+              </a:rPr>
+              <a:t>Maîtriser les coûts de l'IA</a:t>
+            </a:r>
+            <a:endParaRPr lang="en-US" sz="1700" dirty="0"/>
+          </a:p>
+        </p:txBody>
+      </p:sp>
+      <p:sp>
+        <p:nvSpPr>
+          <p:cNvPr id="13" name="Text 11"/>
+          <p:cNvSpPr/>
+          <p:nvPr/>
+        </p:nvSpPr>
+        <p:spPr>
+          <a:xfrm>
+            <a:off x="6592824" y="2926080"/>
+            <a:ext cx="4663440" cy="685800"/>
+          </a:xfrm>
+          <a:prstGeom prst="rect">
+            <a:avLst/>
+          </a:prstGeom>
+          <a:noFill/>
+          <a:ln/>
+        </p:spPr>
+        <p:txBody>
+          <a:bodyPr wrap="square" lIns="0" tIns="0" rIns="0" bIns="0" rtlCol="0" anchor="ctr"/>
+          <a:lstStyle/>
+          <a:p>
+            <a:pPr indent="0" marL="0">
+              <a:lnSpc>
+                <a:spcPct val="115000"/>
+              </a:lnSpc>
+              <a:buNone/>
+            </a:pPr>
+            <a:r>
+              <a:rPr lang="en-US" sz="1300" dirty="0">
+                <a:solidFill>
+                  <a:srgbClr val="535462"/>
+                </a:solidFill>
+                <a:latin typeface="Montserrat" pitchFamily="34" charset="0"/>
+                <a:ea typeface="Montserrat" pitchFamily="34" charset="-122"/>
+                <a:cs typeface="Montserrat" pitchFamily="34" charset="-120"/>
+              </a:rPr>
+              <a:t>Une visibilité sur la consommation et le coût réel de l'usage de l'IA.</a:t>
+            </a:r>
+            <a:endParaRPr lang="en-US" sz="1300" dirty="0"/>
+          </a:p>
+        </p:txBody>
+      </p:sp>
+      <p:sp>
+        <p:nvSpPr>
+          <p:cNvPr id="14" name="Shape 12"/>
+          <p:cNvSpPr/>
+          <p:nvPr/>
+        </p:nvSpPr>
+        <p:spPr>
+          <a:xfrm>
+            <a:off x="640080" y="3886200"/>
+            <a:ext cx="5276088" cy="1691640"/>
+          </a:xfrm>
+          <a:prstGeom prst="roundRect">
+            <a:avLst>
+              <a:gd name="adj" fmla="val 5405"/>
+            </a:avLst>
+          </a:prstGeom>
+          <a:solidFill>
+            <a:srgbClr val="FFFFFF"/>
+          </a:solidFill>
+          <a:ln w="12700">
+            <a:solidFill>
+              <a:srgbClr val="E8E8EE"/>
+            </a:solidFill>
+            <a:prstDash val="solid"/>
+          </a:ln>
+          <a:effectLst>
+            <a:outerShdw sx="100000" sy="100000" kx="0" ky="0" algn="bl" rotWithShape="0" blurRad="114300" dist="38100" dir="5400000">
+              <a:srgbClr val="10122A">
+                <a:alpha val="12000"/>
+              </a:srgbClr>
+            </a:outerShdw>
+          </a:effectLst>
+        </p:spPr>
+      </p:sp>
+      <p:sp>
+        <p:nvSpPr>
+          <p:cNvPr id="15" name="Shape 13"/>
+          <p:cNvSpPr/>
+          <p:nvPr/>
+        </p:nvSpPr>
+        <p:spPr>
+          <a:xfrm>
+            <a:off x="960120" y="4206240"/>
+            <a:ext cx="457200" cy="457200"/>
+          </a:xfrm>
+          <a:prstGeom prst="roundRect">
+            <a:avLst>
+              <a:gd name="adj" fmla="val 16000"/>
+            </a:avLst>
+          </a:prstGeom>
+          <a:solidFill>
+            <a:srgbClr val="8047F4"/>
+          </a:solidFill>
+          <a:ln/>
+        </p:spPr>
+      </p:sp>
+      <p:sp>
+        <p:nvSpPr>
+          <p:cNvPr id="16" name="Text 14"/>
+          <p:cNvSpPr/>
+          <p:nvPr/>
+        </p:nvSpPr>
+        <p:spPr>
+          <a:xfrm>
+            <a:off x="960120" y="4206240"/>
+            <a:ext cx="457200" cy="457200"/>
+          </a:xfrm>
+          <a:prstGeom prst="rect">
+            <a:avLst/>
+          </a:prstGeom>
+          <a:noFill/>
+          <a:ln/>
+        </p:spPr>
+        <p:txBody>
+          <a:bodyPr wrap="square" lIns="0" tIns="0" rIns="0" bIns="0" rtlCol="0" anchor="ctr"/>
+          <a:lstStyle/>
+          <a:p>
+            <a:pPr algn="ctr" indent="0" marL="0">
+              <a:buNone/>
+            </a:pPr>
+            <a:r>
+              <a:rPr lang="en-US" sz="1300" b="1" dirty="0">
+                <a:solidFill>
+                  <a:srgbClr val="FFFFFF"/>
+                </a:solidFill>
+                <a:latin typeface="JetBrains Mono" pitchFamily="34" charset="0"/>
+                <a:ea typeface="JetBrains Mono" pitchFamily="34" charset="-122"/>
+                <a:cs typeface="JetBrains Mono" pitchFamily="34" charset="-120"/>
+              </a:rPr>
+              <a:t>3</a:t>
+            </a:r>
+            <a:endParaRPr lang="en-US" sz="1300" dirty="0"/>
+          </a:p>
+        </p:txBody>
+      </p:sp>
+      <p:sp>
+        <p:nvSpPr>
+          <p:cNvPr id="17" name="Text 15"/>
+          <p:cNvSpPr/>
+          <p:nvPr/>
+        </p:nvSpPr>
+        <p:spPr>
+          <a:xfrm>
+            <a:off x="1600200" y="4178808"/>
+            <a:ext cx="4023360" cy="548640"/>
+          </a:xfrm>
+          <a:prstGeom prst="rect">
+            <a:avLst/>
+          </a:prstGeom>
+          <a:noFill/>
+          <a:ln/>
+        </p:spPr>
+        <p:txBody>
+          <a:bodyPr wrap="square" lIns="0" tIns="0" rIns="0" bIns="0" rtlCol="0" anchor="ctr"/>
+          <a:lstStyle/>
+          <a:p>
+            <a:pPr indent="0" marL="0">
+              <a:buNone/>
+            </a:pPr>
+            <a:r>
+              <a:rPr lang="en-US" sz="1700" b="1" dirty="0">
+                <a:solidFill>
+                  <a:srgbClr val="0A0A0A"/>
+                </a:solidFill>
+                <a:latin typeface="Space Grotesk" pitchFamily="34" charset="0"/>
+                <a:ea typeface="Space Grotesk" pitchFamily="34" charset="-122"/>
+                <a:cs typeface="Space Grotesk" pitchFamily="34" charset="-120"/>
+              </a:rPr>
+              <a:t>Reprendre le legacy en main</a:t>
+            </a:r>
+            <a:endParaRPr lang="en-US" sz="1700" dirty="0"/>
+          </a:p>
+        </p:txBody>
+      </p:sp>
+      <p:sp>
+        <p:nvSpPr>
+          <p:cNvPr id="18" name="Text 16"/>
+          <p:cNvSpPr/>
+          <p:nvPr/>
+        </p:nvSpPr>
+        <p:spPr>
+          <a:xfrm>
+            <a:off x="960120" y="4800600"/>
+            <a:ext cx="4663440" cy="685800"/>
+          </a:xfrm>
+          <a:prstGeom prst="rect">
+            <a:avLst/>
+          </a:prstGeom>
+          <a:noFill/>
+          <a:ln/>
+        </p:spPr>
+        <p:txBody>
+          <a:bodyPr wrap="square" lIns="0" tIns="0" rIns="0" bIns="0" rtlCol="0" anchor="ctr"/>
+          <a:lstStyle/>
+          <a:p>
+            <a:pPr indent="0" marL="0">
+              <a:lnSpc>
+                <a:spcPct val="115000"/>
+              </a:lnSpc>
+              <a:buNone/>
+            </a:pPr>
+            <a:r>
+              <a:rPr lang="en-US" sz="1300" dirty="0">
+                <a:solidFill>
+                  <a:srgbClr val="535462"/>
+                </a:solidFill>
+                <a:latin typeface="Montserrat" pitchFamily="34" charset="0"/>
+                <a:ea typeface="Montserrat" pitchFamily="34" charset="-122"/>
+                <a:cs typeface="Montserrat" pitchFamily="34" charset="-120"/>
+              </a:rPr>
+              <a:t>Re-cartographier l'existant et retrouver de la maîtrise sur le legacy.</a:t>
+            </a:r>
+            <a:endParaRPr lang="en-US" sz="1300" dirty="0"/>
+          </a:p>
+        </p:txBody>
+      </p:sp>
+      <p:sp>
+        <p:nvSpPr>
+          <p:cNvPr id="19" name="Shape 17"/>
+          <p:cNvSpPr/>
+          <p:nvPr/>
+        </p:nvSpPr>
+        <p:spPr>
+          <a:xfrm>
+            <a:off x="6272784" y="3886200"/>
+            <a:ext cx="5276088" cy="1691640"/>
+          </a:xfrm>
+          <a:prstGeom prst="roundRect">
+            <a:avLst>
+              <a:gd name="adj" fmla="val 5405"/>
+            </a:avLst>
+          </a:prstGeom>
+          <a:solidFill>
+            <a:srgbClr val="FFFFFF"/>
+          </a:solidFill>
+          <a:ln w="12700">
+            <a:solidFill>
+              <a:srgbClr val="E8E8EE"/>
+            </a:solidFill>
+            <a:prstDash val="solid"/>
+          </a:ln>
+          <a:effectLst>
+            <a:outerShdw sx="100000" sy="100000" kx="0" ky="0" algn="bl" rotWithShape="0" blurRad="114300" dist="38100" dir="5400000">
+              <a:srgbClr val="10122A">
+                <a:alpha val="12000"/>
+              </a:srgbClr>
+            </a:outerShdw>
+          </a:effectLst>
+        </p:spPr>
+      </p:sp>
+      <p:sp>
+        <p:nvSpPr>
+          <p:cNvPr id="20" name="Shape 18"/>
+          <p:cNvSpPr/>
+          <p:nvPr/>
+        </p:nvSpPr>
+        <p:spPr>
+          <a:xfrm>
+            <a:off x="6592824" y="4206240"/>
+            <a:ext cx="457200" cy="457200"/>
+          </a:xfrm>
+          <a:prstGeom prst="roundRect">
+            <a:avLst>
+              <a:gd name="adj" fmla="val 16000"/>
+            </a:avLst>
+          </a:prstGeom>
+          <a:solidFill>
+            <a:srgbClr val="1FA98A"/>
+          </a:solidFill>
+          <a:ln/>
+        </p:spPr>
+      </p:sp>
+      <p:sp>
+        <p:nvSpPr>
+          <p:cNvPr id="21" name="Text 19"/>
+          <p:cNvSpPr/>
+          <p:nvPr/>
+        </p:nvSpPr>
+        <p:spPr>
+          <a:xfrm>
+            <a:off x="6592824" y="4206240"/>
+            <a:ext cx="457200" cy="457200"/>
+          </a:xfrm>
+          <a:prstGeom prst="rect">
+            <a:avLst/>
+          </a:prstGeom>
+          <a:noFill/>
+          <a:ln/>
+        </p:spPr>
+        <p:txBody>
+          <a:bodyPr wrap="square" lIns="0" tIns="0" rIns="0" bIns="0" rtlCol="0" anchor="ctr"/>
+          <a:lstStyle/>
+          <a:p>
+            <a:pPr algn="ctr" indent="0" marL="0">
+              <a:buNone/>
+            </a:pPr>
+            <a:r>
+              <a:rPr lang="en-US" sz="1300" b="1" dirty="0">
+                <a:solidFill>
+                  <a:srgbClr val="FFFFFF"/>
+                </a:solidFill>
+                <a:latin typeface="JetBrains Mono" pitchFamily="34" charset="0"/>
+                <a:ea typeface="JetBrains Mono" pitchFamily="34" charset="-122"/>
+                <a:cs typeface="JetBrains Mono" pitchFamily="34" charset="-120"/>
+              </a:rPr>
+              <a:t>4</a:t>
+            </a:r>
+            <a:endParaRPr lang="en-US" sz="1300" dirty="0"/>
+          </a:p>
+        </p:txBody>
+      </p:sp>
+      <p:sp>
+        <p:nvSpPr>
+          <p:cNvPr id="22" name="Text 20"/>
+          <p:cNvSpPr/>
+          <p:nvPr/>
+        </p:nvSpPr>
+        <p:spPr>
+          <a:xfrm>
+            <a:off x="7232904" y="4178808"/>
+            <a:ext cx="4023360" cy="548640"/>
+          </a:xfrm>
+          <a:prstGeom prst="rect">
+            <a:avLst/>
+          </a:prstGeom>
+          <a:noFill/>
+          <a:ln/>
+        </p:spPr>
+        <p:txBody>
+          <a:bodyPr wrap="square" lIns="0" tIns="0" rIns="0" bIns="0" rtlCol="0" anchor="ctr"/>
+          <a:lstStyle/>
+          <a:p>
+            <a:pPr indent="0" marL="0">
+              <a:buNone/>
+            </a:pPr>
+            <a:r>
+              <a:rPr lang="en-US" sz="1700" b="1" dirty="0">
+                <a:solidFill>
+                  <a:srgbClr val="0A0A0A"/>
+                </a:solidFill>
+                <a:latin typeface="Space Grotesk" pitchFamily="34" charset="0"/>
+                <a:ea typeface="Space Grotesk" pitchFamily="34" charset="-122"/>
+                <a:cs typeface="Space Grotesk" pitchFamily="34" charset="-120"/>
+              </a:rPr>
+              <a:t>Superviser les ways of working</a:t>
+            </a:r>
+            <a:endParaRPr lang="en-US" sz="1700" dirty="0"/>
+          </a:p>
+        </p:txBody>
+      </p:sp>
+      <p:sp>
+        <p:nvSpPr>
+          <p:cNvPr id="23" name="Text 21"/>
+          <p:cNvSpPr/>
+          <p:nvPr/>
+        </p:nvSpPr>
+        <p:spPr>
+          <a:xfrm>
+            <a:off x="6592824" y="4800600"/>
+            <a:ext cx="4663440" cy="685800"/>
+          </a:xfrm>
+          <a:prstGeom prst="rect">
+            <a:avLst/>
+          </a:prstGeom>
+          <a:noFill/>
+          <a:ln/>
+        </p:spPr>
+        <p:txBody>
+          <a:bodyPr wrap="square" lIns="0" tIns="0" rIns="0" bIns="0" rtlCol="0" anchor="ctr"/>
+          <a:lstStyle/>
+          <a:p>
+            <a:pPr indent="0" marL="0">
+              <a:lnSpc>
+                <a:spcPct val="115000"/>
+              </a:lnSpc>
+              <a:buNone/>
+            </a:pPr>
+            <a:r>
+              <a:rPr lang="en-US" sz="1300" dirty="0">
+                <a:solidFill>
+                  <a:srgbClr val="535462"/>
+                </a:solidFill>
+                <a:latin typeface="Montserrat" pitchFamily="34" charset="0"/>
+                <a:ea typeface="Montserrat" pitchFamily="34" charset="-122"/>
+                <a:cs typeface="Montserrat" pitchFamily="34" charset="-120"/>
+              </a:rPr>
+              <a:t>Rendre les méthodes de travail visibles, encadrées et mesurables.</a:t>
+            </a:r>
+            <a:endParaRPr lang="en-US" sz="1300" dirty="0"/>
+          </a:p>
+        </p:txBody>
+      </p:sp>
+      <p:sp>
+        <p:nvSpPr>
+          <p:cNvPr id="24" name="Text 22"/>
+          <p:cNvSpPr/>
+          <p:nvPr/>
+        </p:nvSpPr>
+        <p:spPr>
+          <a:xfrm>
+            <a:off x="11185855" y="6400800"/>
+            <a:ext cx="548640" cy="274320"/>
+          </a:xfrm>
+          <a:prstGeom prst="rect">
+            <a:avLst/>
+          </a:prstGeom>
+          <a:noFill/>
+          <a:ln/>
+        </p:spPr>
+        <p:txBody>
+          <a:bodyPr wrap="square" lIns="0" tIns="0" rIns="0" bIns="0" rtlCol="0" anchor="ctr"/>
+          <a:lstStyle/>
+          <a:p>
+            <a:pPr algn="r" indent="0" marL="0">
+              <a:buNone/>
+            </a:pPr>
+            <a:r>
+              <a:rPr lang="en-US" sz="1000" dirty="0">
+                <a:solidFill>
+                  <a:srgbClr val="9296A6"/>
+                </a:solidFill>
+                <a:latin typeface="JetBrains Mono" pitchFamily="34" charset="0"/>
+                <a:ea typeface="JetBrains Mono" pitchFamily="34" charset="-122"/>
+                <a:cs typeface="JetBrains Mono" pitchFamily="34" charset="-120"/>
+              </a:rPr>
+              <a:t>10</a:t>
+            </a:r>
+            <a:endParaRPr lang="en-US" sz="1000" dirty="0"/>
+          </a:p>
+        </p:txBody>
+      </p:sp>
+    </p:spTree>
+  </p:cSld>
+  <p:clrMapOvr>
+    <a:masterClrMapping/>
+  </p:clrMapOvr>
+</p:sld>
+</file>
+
+<file path=ppt/slides/slide11.xml><?xml version="1.0" encoding="utf-8"?>
+<p:sld xmlns:a="http://schemas.openxmlformats.org/drawingml/2006/main" xmlns:r="http://schemas.openxmlformats.org/officeDocument/2006/relationships" xmlns:p="http://schemas.openxmlformats.org/presentationml/2006/main">
+  <p:cSld name="Slide 11">
+    <p:bg>
+      <p:bgPr>
+        <a:solidFill>
           <a:srgbClr val="FAFAFC"/>
         </a:solidFill>
       </p:bgPr>
@@ -2516,953 +3458,6 @@
       <p:sp>
         <p:nvSpPr>
           <p:cNvPr id="5" name="Text 3"/>
-          <p:cNvSpPr/>
-          <p:nvPr/>
-        </p:nvSpPr>
-        <p:spPr>
-          <a:xfrm>
-            <a:off x="11185855" y="6400800"/>
-            <a:ext cx="548640" cy="274320"/>
-          </a:xfrm>
-          <a:prstGeom prst="rect">
-            <a:avLst/>
-          </a:prstGeom>
-          <a:noFill/>
-          <a:ln/>
-        </p:spPr>
-        <p:txBody>
-          <a:bodyPr wrap="square" lIns="0" tIns="0" rIns="0" bIns="0" rtlCol="0" anchor="ctr"/>
-          <a:lstStyle/>
-          <a:p>
-            <a:pPr algn="r" indent="0" marL="0">
-              <a:buNone/>
-            </a:pPr>
-            <a:r>
-              <a:rPr lang="en-US" sz="1000" dirty="0">
-                <a:solidFill>
-                  <a:srgbClr val="9296A6"/>
-                </a:solidFill>
-                <a:latin typeface="JetBrains Mono" pitchFamily="34" charset="0"/>
-                <a:ea typeface="JetBrains Mono" pitchFamily="34" charset="-122"/>
-                <a:cs typeface="JetBrains Mono" pitchFamily="34" charset="-120"/>
-              </a:rPr>
-              <a:t>10</a:t>
-            </a:r>
-            <a:endParaRPr lang="en-US" sz="1000" dirty="0"/>
-          </a:p>
-        </p:txBody>
-      </p:sp>
-    </p:spTree>
-  </p:cSld>
-  <p:clrMapOvr>
-    <a:masterClrMapping/>
-  </p:clrMapOvr>
-</p:sld>
-</file>
-
-<file path=ppt/slides/slide11.xml><?xml version="1.0" encoding="utf-8"?>
-<p:sld xmlns:a="http://schemas.openxmlformats.org/drawingml/2006/main" xmlns:r="http://schemas.openxmlformats.org/officeDocument/2006/relationships" xmlns:p="http://schemas.openxmlformats.org/presentationml/2006/main">
-  <p:cSld name="Slide 11">
-    <p:bg>
-      <p:bgPr>
-        <a:solidFill>
-          <a:srgbClr val="FFFFFF"/>
-        </a:solidFill>
-      </p:bgPr>
-    </p:bg>
-    <p:spTree>
-      <p:nvGrpSpPr>
-        <p:cNvPr id="1" name=""/>
-        <p:cNvGrpSpPr/>
-        <p:nvPr/>
-      </p:nvGrpSpPr>
-      <p:grpSpPr>
-        <a:xfrm>
-          <a:off x="0" y="0"/>
-          <a:ext cx="0" cy="0"/>
-          <a:chOff x="0" y="0"/>
-          <a:chExt cx="0" cy="0"/>
-        </a:xfrm>
-      </p:grpSpPr>
-      <p:sp>
-        <p:nvSpPr>
-          <p:cNvPr id="2" name="Text 0"/>
-          <p:cNvSpPr/>
-          <p:nvPr/>
-        </p:nvSpPr>
-        <p:spPr>
-          <a:xfrm>
-            <a:off x="640080" y="640080"/>
-            <a:ext cx="8229600" cy="274320"/>
-          </a:xfrm>
-          <a:prstGeom prst="rect">
-            <a:avLst/>
-          </a:prstGeom>
-          <a:noFill/>
-          <a:ln/>
-        </p:spPr>
-        <p:txBody>
-          <a:bodyPr wrap="square" lIns="0" tIns="0" rIns="0" bIns="0" rtlCol="0" anchor="ctr"/>
-          <a:lstStyle/>
-          <a:p>
-            <a:pPr indent="0" marL="0">
-              <a:buNone/>
-            </a:pPr>
-            <a:r>
-              <a:rPr lang="en-US" sz="1100" b="1" spc="250" kern="0" dirty="0">
-                <a:solidFill>
-                  <a:srgbClr val="FA5FB2"/>
-                </a:solidFill>
-                <a:latin typeface="JetBrains Mono" pitchFamily="34" charset="0"/>
-                <a:ea typeface="JetBrains Mono" pitchFamily="34" charset="-122"/>
-                <a:cs typeface="JetBrains Mono" pitchFamily="34" charset="-120"/>
-              </a:rPr>
-              <a:t>OFFRES &amp; DÉPLOIEMENT</a:t>
-            </a:r>
-            <a:endParaRPr lang="en-US" sz="1100" dirty="0"/>
-          </a:p>
-        </p:txBody>
-      </p:sp>
-      <p:sp>
-        <p:nvSpPr>
-          <p:cNvPr id="3" name="Text 1"/>
-          <p:cNvSpPr/>
-          <p:nvPr/>
-        </p:nvSpPr>
-        <p:spPr>
-          <a:xfrm>
-            <a:off x="640080" y="960120"/>
-            <a:ext cx="10058400" cy="822960"/>
-          </a:xfrm>
-          <a:prstGeom prst="rect">
-            <a:avLst/>
-          </a:prstGeom>
-          <a:noFill/>
-          <a:ln/>
-        </p:spPr>
-        <p:txBody>
-          <a:bodyPr wrap="square" lIns="0" tIns="0" rIns="0" bIns="0" rtlCol="0" anchor="ctr"/>
-          <a:lstStyle/>
-          <a:p>
-            <a:pPr indent="0" marL="0">
-              <a:buNone/>
-            </a:pPr>
-            <a:r>
-              <a:rPr lang="en-US" sz="3000" b="1" dirty="0">
-                <a:solidFill>
-                  <a:srgbClr val="0A0A0A"/>
-                </a:solidFill>
-                <a:latin typeface="Space Grotesk" pitchFamily="34" charset="0"/>
-                <a:ea typeface="Space Grotesk" pitchFamily="34" charset="-122"/>
-                <a:cs typeface="Space Grotesk" pitchFamily="34" charset="-120"/>
-              </a:rPr>
-              <a:t>Choisissez votre mode de déploiement</a:t>
-            </a:r>
-            <a:endParaRPr lang="en-US" sz="3000" dirty="0"/>
-          </a:p>
-        </p:txBody>
-      </p:sp>
-      <p:sp>
-        <p:nvSpPr>
-          <p:cNvPr id="4" name="Shape 2"/>
-          <p:cNvSpPr/>
-          <p:nvPr/>
-        </p:nvSpPr>
-        <p:spPr>
-          <a:xfrm>
-            <a:off x="640080" y="1965960"/>
-            <a:ext cx="3474720" cy="4160520"/>
-          </a:xfrm>
-          <a:prstGeom prst="roundRect">
-            <a:avLst>
-              <a:gd name="adj" fmla="val 2632"/>
-            </a:avLst>
-          </a:prstGeom>
-          <a:solidFill>
-            <a:srgbClr val="FFFFFF"/>
-          </a:solidFill>
-          <a:ln w="12700">
-            <a:solidFill>
-              <a:srgbClr val="E8E8EE"/>
-            </a:solidFill>
-            <a:prstDash val="solid"/>
-          </a:ln>
-          <a:effectLst>
-            <a:outerShdw sx="100000" sy="100000" kx="0" ky="0" algn="bl" rotWithShape="0" blurRad="114300" dist="38100" dir="5400000">
-              <a:srgbClr val="10122A">
-                <a:alpha val="12000"/>
-              </a:srgbClr>
-            </a:outerShdw>
-          </a:effectLst>
-        </p:spPr>
-      </p:sp>
-      <p:sp>
-        <p:nvSpPr>
-          <p:cNvPr id="5" name="Text 3"/>
-          <p:cNvSpPr/>
-          <p:nvPr/>
-        </p:nvSpPr>
-        <p:spPr>
-          <a:xfrm>
-            <a:off x="932688" y="2240280"/>
-            <a:ext cx="2926080" cy="411480"/>
-          </a:xfrm>
-          <a:prstGeom prst="rect">
-            <a:avLst/>
-          </a:prstGeom>
-          <a:noFill/>
-          <a:ln/>
-        </p:spPr>
-        <p:txBody>
-          <a:bodyPr wrap="square" lIns="0" tIns="0" rIns="0" bIns="0" rtlCol="0" anchor="ctr"/>
-          <a:lstStyle/>
-          <a:p>
-            <a:pPr indent="0" marL="0">
-              <a:buNone/>
-            </a:pPr>
-            <a:r>
-              <a:rPr lang="en-US" sz="2000" b="1" dirty="0">
-                <a:solidFill>
-                  <a:srgbClr val="BB46F5"/>
-                </a:solidFill>
-                <a:latin typeface="Space Grotesk" pitchFamily="34" charset="0"/>
-                <a:ea typeface="Space Grotesk" pitchFamily="34" charset="-122"/>
-                <a:cs typeface="Space Grotesk" pitchFamily="34" charset="-120"/>
-              </a:rPr>
-              <a:t>Community</a:t>
-            </a:r>
-            <a:endParaRPr lang="en-US" sz="2000" dirty="0"/>
-          </a:p>
-        </p:txBody>
-      </p:sp>
-      <p:sp>
-        <p:nvSpPr>
-          <p:cNvPr id="6" name="Text 4"/>
-          <p:cNvSpPr/>
-          <p:nvPr/>
-        </p:nvSpPr>
-        <p:spPr>
-          <a:xfrm>
-            <a:off x="932688" y="2670048"/>
-            <a:ext cx="2926080" cy="320040"/>
-          </a:xfrm>
-          <a:prstGeom prst="rect">
-            <a:avLst/>
-          </a:prstGeom>
-          <a:noFill/>
-          <a:ln/>
-        </p:spPr>
-        <p:txBody>
-          <a:bodyPr wrap="square" lIns="0" tIns="0" rIns="0" bIns="0" rtlCol="0" anchor="ctr"/>
-          <a:lstStyle/>
-          <a:p>
-            <a:pPr indent="0" marL="0">
-              <a:buNone/>
-            </a:pPr>
-            <a:r>
-              <a:rPr lang="en-US" sz="1050" spc="50" kern="0" dirty="0">
-                <a:solidFill>
-                  <a:srgbClr val="9296A6"/>
-                </a:solidFill>
-                <a:latin typeface="JetBrains Mono" pitchFamily="34" charset="0"/>
-                <a:ea typeface="JetBrains Mono" pitchFamily="34" charset="-122"/>
-                <a:cs typeface="JetBrains Mono" pitchFamily="34" charset="-120"/>
-              </a:rPr>
-              <a:t>Open source · AGPL</a:t>
-            </a:r>
-            <a:endParaRPr lang="en-US" sz="1050" dirty="0"/>
-          </a:p>
-        </p:txBody>
-      </p:sp>
-      <p:sp>
-        <p:nvSpPr>
-          <p:cNvPr id="7" name="Text 5"/>
-          <p:cNvSpPr/>
-          <p:nvPr/>
-        </p:nvSpPr>
-        <p:spPr>
-          <a:xfrm>
-            <a:off x="932688" y="3154680"/>
-            <a:ext cx="2926080" cy="2103120"/>
-          </a:xfrm>
-          <a:prstGeom prst="rect">
-            <a:avLst/>
-          </a:prstGeom>
-          <a:noFill/>
-          <a:ln/>
-        </p:spPr>
-        <p:txBody>
-          <a:bodyPr wrap="square" lIns="0" tIns="0" rIns="0" bIns="0" rtlCol="0" anchor="ctr"/>
-          <a:lstStyle/>
-          <a:p>
-            <a:pPr marL="177800" indent="-177800">
-              <a:lnSpc>
-                <a:spcPct val="105000"/>
-              </a:lnSpc>
-              <a:spcAft>
-                <a:spcPts val="900"/>
-              </a:spcAft>
-              <a:buSzPct val="100000"/>
-              <a:buChar char="•"/>
-            </a:pPr>
-            <a:r>
-              <a:rPr lang="en-US" sz="1200" dirty="0">
-                <a:solidFill>
-                  <a:srgbClr val="1A1A1A"/>
-                </a:solidFill>
-                <a:latin typeface="Montserrat" pitchFamily="34" charset="0"/>
-                <a:ea typeface="Montserrat" pitchFamily="34" charset="-122"/>
-                <a:cs typeface="Montserrat" pitchFamily="34" charset="-120"/>
-              </a:rPr>
-              <a:t>Self-hébergé, sur vos serveurs</a:t>
-            </a:r>
-            <a:endParaRPr lang="en-US" sz="1200" dirty="0"/>
-          </a:p>
-          <a:p>
-            <a:pPr marL="177800" indent="-177800">
-              <a:lnSpc>
-                <a:spcPct val="105000"/>
-              </a:lnSpc>
-              <a:spcAft>
-                <a:spcPts val="900"/>
-              </a:spcAft>
-              <a:buSzPct val="100000"/>
-              <a:buChar char="•"/>
-            </a:pPr>
-            <a:r>
-              <a:rPr lang="en-US" sz="1200" dirty="0">
-                <a:solidFill>
-                  <a:srgbClr val="1A1A1A"/>
-                </a:solidFill>
-                <a:latin typeface="Montserrat" pitchFamily="34" charset="0"/>
-                <a:ea typeface="Montserrat" pitchFamily="34" charset="-122"/>
-                <a:cs typeface="Montserrat" pitchFamily="34" charset="-120"/>
-              </a:rPr>
-              <a:t>Modélisation produit complète</a:t>
-            </a:r>
-            <a:endParaRPr lang="en-US" sz="1200" dirty="0"/>
-          </a:p>
-          <a:p>
-            <a:pPr marL="177800" indent="-177800">
-              <a:lnSpc>
-                <a:spcPct val="105000"/>
-              </a:lnSpc>
-              <a:spcAft>
-                <a:spcPts val="900"/>
-              </a:spcAft>
-              <a:buSzPct val="100000"/>
-              <a:buChar char="•"/>
-            </a:pPr>
-            <a:r>
-              <a:rPr lang="en-US" sz="1200" dirty="0">
-                <a:solidFill>
-                  <a:srgbClr val="1A1A1A"/>
-                </a:solidFill>
-                <a:latin typeface="Montserrat" pitchFamily="34" charset="0"/>
-                <a:ea typeface="Montserrat" pitchFamily="34" charset="-122"/>
-                <a:cs typeface="Montserrat" pitchFamily="34" charset="-120"/>
-              </a:rPr>
-              <a:t>Spécifications prêtes pour l'IA</a:t>
-            </a:r>
-            <a:endParaRPr lang="en-US" sz="1200" dirty="0"/>
-          </a:p>
-          <a:p>
-            <a:pPr marL="177800" indent="-177800">
-              <a:lnSpc>
-                <a:spcPct val="105000"/>
-              </a:lnSpc>
-              <a:buSzPct val="100000"/>
-              <a:buChar char="•"/>
-            </a:pPr>
-            <a:r>
-              <a:rPr lang="en-US" sz="1200" dirty="0">
-                <a:solidFill>
-                  <a:srgbClr val="1A1A1A"/>
-                </a:solidFill>
-                <a:latin typeface="Montserrat" pitchFamily="34" charset="0"/>
-                <a:ea typeface="Montserrat" pitchFamily="34" charset="-122"/>
-                <a:cs typeface="Montserrat" pitchFamily="34" charset="-120"/>
-              </a:rPr>
-              <a:t>Contrôles de cohérence essentiels</a:t>
-            </a:r>
-            <a:endParaRPr lang="en-US" sz="1200" dirty="0"/>
-          </a:p>
-        </p:txBody>
-      </p:sp>
-      <p:sp>
-        <p:nvSpPr>
-          <p:cNvPr id="8" name="Text 6"/>
-          <p:cNvSpPr/>
-          <p:nvPr/>
-        </p:nvSpPr>
-        <p:spPr>
-          <a:xfrm>
-            <a:off x="932688" y="5532120"/>
-            <a:ext cx="2926080" cy="365760"/>
-          </a:xfrm>
-          <a:prstGeom prst="rect">
-            <a:avLst/>
-          </a:prstGeom>
-          <a:noFill/>
-          <a:ln/>
-        </p:spPr>
-        <p:txBody>
-          <a:bodyPr wrap="square" lIns="0" tIns="0" rIns="0" bIns="0" rtlCol="0" anchor="ctr"/>
-          <a:lstStyle/>
-          <a:p>
-            <a:pPr indent="0" marL="0">
-              <a:buNone/>
-            </a:pPr>
-            <a:r>
-              <a:rPr lang="en-US" sz="1250" b="1" dirty="0">
-                <a:solidFill>
-                  <a:srgbClr val="BB46F5"/>
-                </a:solidFill>
-                <a:latin typeface="Montserrat" pitchFamily="34" charset="0"/>
-                <a:ea typeface="Montserrat" pitchFamily="34" charset="-122"/>
-                <a:cs typeface="Montserrat" pitchFamily="34" charset="-120"/>
-              </a:rPr>
-              <a:t>Voir sur GitHub  →</a:t>
-            </a:r>
-            <a:endParaRPr lang="en-US" sz="1250" dirty="0"/>
-          </a:p>
-        </p:txBody>
-      </p:sp>
-      <p:sp>
-        <p:nvSpPr>
-          <p:cNvPr id="9" name="Shape 7"/>
-          <p:cNvSpPr/>
-          <p:nvPr/>
-        </p:nvSpPr>
-        <p:spPr>
-          <a:xfrm>
-            <a:off x="4398264" y="1965960"/>
-            <a:ext cx="3474720" cy="4160520"/>
-          </a:xfrm>
-          <a:prstGeom prst="roundRect">
-            <a:avLst>
-              <a:gd name="adj" fmla="val 2632"/>
-            </a:avLst>
-          </a:prstGeom>
-          <a:solidFill>
-            <a:srgbClr val="FFFFFF"/>
-          </a:solidFill>
-          <a:ln w="12700">
-            <a:solidFill>
-              <a:srgbClr val="E8E8EE"/>
-            </a:solidFill>
-            <a:prstDash val="solid"/>
-          </a:ln>
-          <a:effectLst>
-            <a:outerShdw sx="100000" sy="100000" kx="0" ky="0" algn="bl" rotWithShape="0" blurRad="114300" dist="38100" dir="5400000">
-              <a:srgbClr val="10122A">
-                <a:alpha val="12000"/>
-              </a:srgbClr>
-            </a:outerShdw>
-          </a:effectLst>
-        </p:spPr>
-      </p:sp>
-      <p:sp>
-        <p:nvSpPr>
-          <p:cNvPr id="10" name="Text 8"/>
-          <p:cNvSpPr/>
-          <p:nvPr/>
-        </p:nvSpPr>
-        <p:spPr>
-          <a:xfrm>
-            <a:off x="4690872" y="2240280"/>
-            <a:ext cx="2926080" cy="411480"/>
-          </a:xfrm>
-          <a:prstGeom prst="rect">
-            <a:avLst/>
-          </a:prstGeom>
-          <a:noFill/>
-          <a:ln/>
-        </p:spPr>
-        <p:txBody>
-          <a:bodyPr wrap="square" lIns="0" tIns="0" rIns="0" bIns="0" rtlCol="0" anchor="ctr"/>
-          <a:lstStyle/>
-          <a:p>
-            <a:pPr indent="0" marL="0">
-              <a:buNone/>
-            </a:pPr>
-            <a:r>
-              <a:rPr lang="en-US" sz="2000" b="1" dirty="0">
-                <a:solidFill>
-                  <a:srgbClr val="0066FF"/>
-                </a:solidFill>
-                <a:latin typeface="Space Grotesk" pitchFamily="34" charset="0"/>
-                <a:ea typeface="Space Grotesk" pitchFamily="34" charset="-122"/>
-                <a:cs typeface="Space Grotesk" pitchFamily="34" charset="-120"/>
-              </a:rPr>
-              <a:t>Enterprise</a:t>
-            </a:r>
-            <a:endParaRPr lang="en-US" sz="2000" dirty="0"/>
-          </a:p>
-        </p:txBody>
-      </p:sp>
-      <p:sp>
-        <p:nvSpPr>
-          <p:cNvPr id="11" name="Text 9"/>
-          <p:cNvSpPr/>
-          <p:nvPr/>
-        </p:nvSpPr>
-        <p:spPr>
-          <a:xfrm>
-            <a:off x="4690872" y="2670048"/>
-            <a:ext cx="2926080" cy="320040"/>
-          </a:xfrm>
-          <a:prstGeom prst="rect">
-            <a:avLst/>
-          </a:prstGeom>
-          <a:noFill/>
-          <a:ln/>
-        </p:spPr>
-        <p:txBody>
-          <a:bodyPr wrap="square" lIns="0" tIns="0" rIns="0" bIns="0" rtlCol="0" anchor="ctr"/>
-          <a:lstStyle/>
-          <a:p>
-            <a:pPr indent="0" marL="0">
-              <a:buNone/>
-            </a:pPr>
-            <a:r>
-              <a:rPr lang="en-US" sz="1050" spc="50" kern="0" dirty="0">
-                <a:solidFill>
-                  <a:srgbClr val="9296A6"/>
-                </a:solidFill>
-                <a:latin typeface="JetBrains Mono" pitchFamily="34" charset="0"/>
-                <a:ea typeface="JetBrains Mono" pitchFamily="34" charset="-122"/>
-                <a:cs typeface="JetBrains Mono" pitchFamily="34" charset="-120"/>
-              </a:rPr>
-              <a:t>Licence annuelle · self-service</a:t>
-            </a:r>
-            <a:endParaRPr lang="en-US" sz="1050" dirty="0"/>
-          </a:p>
-        </p:txBody>
-      </p:sp>
-      <p:sp>
-        <p:nvSpPr>
-          <p:cNvPr id="12" name="Text 10"/>
-          <p:cNvSpPr/>
-          <p:nvPr/>
-        </p:nvSpPr>
-        <p:spPr>
-          <a:xfrm>
-            <a:off x="4690872" y="3154680"/>
-            <a:ext cx="2926080" cy="2103120"/>
-          </a:xfrm>
-          <a:prstGeom prst="rect">
-            <a:avLst/>
-          </a:prstGeom>
-          <a:noFill/>
-          <a:ln/>
-        </p:spPr>
-        <p:txBody>
-          <a:bodyPr wrap="square" lIns="0" tIns="0" rIns="0" bIns="0" rtlCol="0" anchor="ctr"/>
-          <a:lstStyle/>
-          <a:p>
-            <a:pPr marL="177800" indent="-177800">
-              <a:lnSpc>
-                <a:spcPct val="105000"/>
-              </a:lnSpc>
-              <a:spcAft>
-                <a:spcPts val="900"/>
-              </a:spcAft>
-              <a:buSzPct val="100000"/>
-              <a:buChar char="•"/>
-            </a:pPr>
-            <a:r>
-              <a:rPr lang="en-US" sz="1200" dirty="0">
-                <a:solidFill>
-                  <a:srgbClr val="1A1A1A"/>
-                </a:solidFill>
-                <a:latin typeface="Montserrat" pitchFamily="34" charset="0"/>
-                <a:ea typeface="Montserrat" pitchFamily="34" charset="-122"/>
-                <a:cs typeface="Montserrat" pitchFamily="34" charset="-120"/>
-              </a:rPr>
-              <a:t>Équipes multi-utilisateurs</a:t>
-            </a:r>
-            <a:endParaRPr lang="en-US" sz="1200" dirty="0"/>
-          </a:p>
-          <a:p>
-            <a:pPr marL="177800" indent="-177800">
-              <a:lnSpc>
-                <a:spcPct val="105000"/>
-              </a:lnSpc>
-              <a:spcAft>
-                <a:spcPts val="900"/>
-              </a:spcAft>
-              <a:buSzPct val="100000"/>
-              <a:buChar char="•"/>
-            </a:pPr>
-            <a:r>
-              <a:rPr lang="en-US" sz="1200" dirty="0">
-                <a:solidFill>
-                  <a:srgbClr val="1A1A1A"/>
-                </a:solidFill>
-                <a:latin typeface="Montserrat" pitchFamily="34" charset="0"/>
-                <a:ea typeface="Montserrat" pitchFamily="34" charset="-122"/>
-                <a:cs typeface="Montserrat" pitchFamily="34" charset="-120"/>
-              </a:rPr>
-              <a:t>Gestion des droits &amp; rôles</a:t>
-            </a:r>
-            <a:endParaRPr lang="en-US" sz="1200" dirty="0"/>
-          </a:p>
-          <a:p>
-            <a:pPr marL="177800" indent="-177800">
-              <a:lnSpc>
-                <a:spcPct val="105000"/>
-              </a:lnSpc>
-              <a:spcAft>
-                <a:spcPts val="900"/>
-              </a:spcAft>
-              <a:buSzPct val="100000"/>
-              <a:buChar char="•"/>
-            </a:pPr>
-            <a:r>
-              <a:rPr lang="en-US" sz="1200" dirty="0">
-                <a:solidFill>
-                  <a:srgbClr val="1A1A1A"/>
-                </a:solidFill>
-                <a:latin typeface="Montserrat" pitchFamily="34" charset="0"/>
-                <a:ea typeface="Montserrat" pitchFamily="34" charset="-122"/>
-                <a:cs typeface="Montserrat" pitchFamily="34" charset="-120"/>
-              </a:rPr>
-              <a:t>Collaboration en temps réel</a:t>
-            </a:r>
-            <a:endParaRPr lang="en-US" sz="1200" dirty="0"/>
-          </a:p>
-          <a:p>
-            <a:pPr marL="177800" indent="-177800">
-              <a:lnSpc>
-                <a:spcPct val="105000"/>
-              </a:lnSpc>
-              <a:buSzPct val="100000"/>
-              <a:buChar char="•"/>
-            </a:pPr>
-            <a:r>
-              <a:rPr lang="en-US" sz="1200" dirty="0">
-                <a:solidFill>
-                  <a:srgbClr val="1A1A1A"/>
-                </a:solidFill>
-                <a:latin typeface="Montserrat" pitchFamily="34" charset="0"/>
-                <a:ea typeface="Montserrat" pitchFamily="34" charset="-122"/>
-                <a:cs typeface="Montserrat" pitchFamily="34" charset="-120"/>
-              </a:rPr>
-              <a:t>Vérification après implémentation</a:t>
-            </a:r>
-            <a:endParaRPr lang="en-US" sz="1200" dirty="0"/>
-          </a:p>
-        </p:txBody>
-      </p:sp>
-      <p:sp>
-        <p:nvSpPr>
-          <p:cNvPr id="13" name="Text 11"/>
-          <p:cNvSpPr/>
-          <p:nvPr/>
-        </p:nvSpPr>
-        <p:spPr>
-          <a:xfrm>
-            <a:off x="4690872" y="5532120"/>
-            <a:ext cx="2926080" cy="365760"/>
-          </a:xfrm>
-          <a:prstGeom prst="rect">
-            <a:avLst/>
-          </a:prstGeom>
-          <a:noFill/>
-          <a:ln/>
-        </p:spPr>
-        <p:txBody>
-          <a:bodyPr wrap="square" lIns="0" tIns="0" rIns="0" bIns="0" rtlCol="0" anchor="ctr"/>
-          <a:lstStyle/>
-          <a:p>
-            <a:pPr indent="0" marL="0">
-              <a:buNone/>
-            </a:pPr>
-            <a:r>
-              <a:rPr lang="en-US" sz="1250" b="1" dirty="0">
-                <a:solidFill>
-                  <a:srgbClr val="0066FF"/>
-                </a:solidFill>
-                <a:latin typeface="Montserrat" pitchFamily="34" charset="0"/>
-                <a:ea typeface="Montserrat" pitchFamily="34" charset="-122"/>
-                <a:cs typeface="Montserrat" pitchFamily="34" charset="-120"/>
-              </a:rPr>
-              <a:t>Demander un devis  →</a:t>
-            </a:r>
-            <a:endParaRPr lang="en-US" sz="1250" dirty="0"/>
-          </a:p>
-        </p:txBody>
-      </p:sp>
-      <p:sp>
-        <p:nvSpPr>
-          <p:cNvPr id="14" name="Shape 12"/>
-          <p:cNvSpPr/>
-          <p:nvPr/>
-        </p:nvSpPr>
-        <p:spPr>
-          <a:xfrm>
-            <a:off x="8156448" y="1965960"/>
-            <a:ext cx="3474720" cy="4160520"/>
-          </a:xfrm>
-          <a:prstGeom prst="roundRect">
-            <a:avLst>
-              <a:gd name="adj" fmla="val 2632"/>
-            </a:avLst>
-          </a:prstGeom>
-          <a:solidFill>
-            <a:srgbClr val="FFFFFF"/>
-          </a:solidFill>
-          <a:ln w="12700">
-            <a:solidFill>
-              <a:srgbClr val="E8E8EE"/>
-            </a:solidFill>
-            <a:prstDash val="solid"/>
-          </a:ln>
-          <a:effectLst>
-            <a:outerShdw sx="100000" sy="100000" kx="0" ky="0" algn="bl" rotWithShape="0" blurRad="114300" dist="38100" dir="5400000">
-              <a:srgbClr val="10122A">
-                <a:alpha val="12000"/>
-              </a:srgbClr>
-            </a:outerShdw>
-          </a:effectLst>
-        </p:spPr>
-      </p:sp>
-      <p:sp>
-        <p:nvSpPr>
-          <p:cNvPr id="15" name="Text 13"/>
-          <p:cNvSpPr/>
-          <p:nvPr/>
-        </p:nvSpPr>
-        <p:spPr>
-          <a:xfrm>
-            <a:off x="8449056" y="2240280"/>
-            <a:ext cx="2926080" cy="411480"/>
-          </a:xfrm>
-          <a:prstGeom prst="rect">
-            <a:avLst/>
-          </a:prstGeom>
-          <a:noFill/>
-          <a:ln/>
-        </p:spPr>
-        <p:txBody>
-          <a:bodyPr wrap="square" lIns="0" tIns="0" rIns="0" bIns="0" rtlCol="0" anchor="ctr"/>
-          <a:lstStyle/>
-          <a:p>
-            <a:pPr indent="0" marL="0">
-              <a:buNone/>
-            </a:pPr>
-            <a:r>
-              <a:rPr lang="en-US" sz="2000" b="1" dirty="0">
-                <a:solidFill>
-                  <a:srgbClr val="FFA101"/>
-                </a:solidFill>
-                <a:latin typeface="Space Grotesk" pitchFamily="34" charset="0"/>
-                <a:ea typeface="Space Grotesk" pitchFamily="34" charset="-122"/>
-                <a:cs typeface="Space Grotesk" pitchFamily="34" charset="-120"/>
-              </a:rPr>
-              <a:t>Managé</a:t>
-            </a:r>
-            <a:endParaRPr lang="en-US" sz="2000" dirty="0"/>
-          </a:p>
-        </p:txBody>
-      </p:sp>
-      <p:sp>
-        <p:nvSpPr>
-          <p:cNvPr id="16" name="Text 14"/>
-          <p:cNvSpPr/>
-          <p:nvPr/>
-        </p:nvSpPr>
-        <p:spPr>
-          <a:xfrm>
-            <a:off x="8449056" y="2670048"/>
-            <a:ext cx="2926080" cy="320040"/>
-          </a:xfrm>
-          <a:prstGeom prst="rect">
-            <a:avLst/>
-          </a:prstGeom>
-          <a:noFill/>
-          <a:ln/>
-        </p:spPr>
-        <p:txBody>
-          <a:bodyPr wrap="square" lIns="0" tIns="0" rIns="0" bIns="0" rtlCol="0" anchor="ctr"/>
-          <a:lstStyle/>
-          <a:p>
-            <a:pPr indent="0" marL="0">
-              <a:buNone/>
-            </a:pPr>
-            <a:r>
-              <a:rPr lang="en-US" sz="1050" spc="50" kern="0" dirty="0">
-                <a:solidFill>
-                  <a:srgbClr val="9296A6"/>
-                </a:solidFill>
-                <a:latin typeface="JetBrains Mono" pitchFamily="34" charset="0"/>
-                <a:ea typeface="JetBrains Mono" pitchFamily="34" charset="-122"/>
-                <a:cs typeface="JetBrains Mono" pitchFamily="34" charset="-120"/>
-              </a:rPr>
-              <a:t>Hébergé &amp; opéré par Lyriks</a:t>
-            </a:r>
-            <a:endParaRPr lang="en-US" sz="1050" dirty="0"/>
-          </a:p>
-        </p:txBody>
-      </p:sp>
-      <p:sp>
-        <p:nvSpPr>
-          <p:cNvPr id="17" name="Text 15"/>
-          <p:cNvSpPr/>
-          <p:nvPr/>
-        </p:nvSpPr>
-        <p:spPr>
-          <a:xfrm>
-            <a:off x="8449056" y="3154680"/>
-            <a:ext cx="2926080" cy="2103120"/>
-          </a:xfrm>
-          <a:prstGeom prst="rect">
-            <a:avLst/>
-          </a:prstGeom>
-          <a:noFill/>
-          <a:ln/>
-        </p:spPr>
-        <p:txBody>
-          <a:bodyPr wrap="square" lIns="0" tIns="0" rIns="0" bIns="0" rtlCol="0" anchor="ctr"/>
-          <a:lstStyle/>
-          <a:p>
-            <a:pPr marL="177800" indent="-177800">
-              <a:lnSpc>
-                <a:spcPct val="105000"/>
-              </a:lnSpc>
-              <a:spcAft>
-                <a:spcPts val="900"/>
-              </a:spcAft>
-              <a:buSzPct val="100000"/>
-              <a:buChar char="•"/>
-            </a:pPr>
-            <a:r>
-              <a:rPr lang="en-US" sz="1200" dirty="0">
-                <a:solidFill>
-                  <a:srgbClr val="1A1A1A"/>
-                </a:solidFill>
-                <a:latin typeface="Montserrat" pitchFamily="34" charset="0"/>
-                <a:ea typeface="Montserrat" pitchFamily="34" charset="-122"/>
-                <a:cs typeface="Montserrat" pitchFamily="34" charset="-120"/>
-              </a:rPr>
-              <a:t>Infogérance complète &amp; SLA</a:t>
-            </a:r>
-            <a:endParaRPr lang="en-US" sz="1200" dirty="0"/>
-          </a:p>
-          <a:p>
-            <a:pPr marL="177800" indent="-177800">
-              <a:lnSpc>
-                <a:spcPct val="105000"/>
-              </a:lnSpc>
-              <a:spcAft>
-                <a:spcPts val="900"/>
-              </a:spcAft>
-              <a:buSzPct val="100000"/>
-              <a:buChar char="•"/>
-            </a:pPr>
-            <a:r>
-              <a:rPr lang="en-US" sz="1200" dirty="0">
-                <a:solidFill>
-                  <a:srgbClr val="1A1A1A"/>
-                </a:solidFill>
-                <a:latin typeface="Montserrat" pitchFamily="34" charset="0"/>
-                <a:ea typeface="Montserrat" pitchFamily="34" charset="-122"/>
-                <a:cs typeface="Montserrat" pitchFamily="34" charset="-120"/>
-              </a:rPr>
-              <a:t>Supervision avancée des usages IA</a:t>
-            </a:r>
-            <a:endParaRPr lang="en-US" sz="1200" dirty="0"/>
-          </a:p>
-          <a:p>
-            <a:pPr marL="177800" indent="-177800">
-              <a:lnSpc>
-                <a:spcPct val="105000"/>
-              </a:lnSpc>
-              <a:spcAft>
-                <a:spcPts val="900"/>
-              </a:spcAft>
-              <a:buSzPct val="100000"/>
-              <a:buChar char="•"/>
-            </a:pPr>
-            <a:r>
-              <a:rPr lang="en-US" sz="1200" dirty="0">
-                <a:solidFill>
-                  <a:srgbClr val="1A1A1A"/>
-                </a:solidFill>
-                <a:latin typeface="Montserrat" pitchFamily="34" charset="0"/>
-                <a:ea typeface="Montserrat" pitchFamily="34" charset="-122"/>
-                <a:cs typeface="Montserrat" pitchFamily="34" charset="-120"/>
-              </a:rPr>
-              <a:t>SSO &amp; sécurité avancée</a:t>
-            </a:r>
-            <a:endParaRPr lang="en-US" sz="1200" dirty="0"/>
-          </a:p>
-          <a:p>
-            <a:pPr marL="177800" indent="-177800">
-              <a:lnSpc>
-                <a:spcPct val="105000"/>
-              </a:lnSpc>
-              <a:buSzPct val="100000"/>
-              <a:buChar char="•"/>
-            </a:pPr>
-            <a:r>
-              <a:rPr lang="en-US" sz="1200" dirty="0">
-                <a:solidFill>
-                  <a:srgbClr val="1A1A1A"/>
-                </a:solidFill>
-                <a:latin typeface="Montserrat" pitchFamily="34" charset="0"/>
-                <a:ea typeface="Montserrat" pitchFamily="34" charset="-122"/>
-                <a:cs typeface="Montserrat" pitchFamily="34" charset="-120"/>
-              </a:rPr>
-              <a:t>Accompagnement dédié</a:t>
-            </a:r>
-            <a:endParaRPr lang="en-US" sz="1200" dirty="0"/>
-          </a:p>
-        </p:txBody>
-      </p:sp>
-      <p:sp>
-        <p:nvSpPr>
-          <p:cNvPr id="18" name="Text 16"/>
-          <p:cNvSpPr/>
-          <p:nvPr/>
-        </p:nvSpPr>
-        <p:spPr>
-          <a:xfrm>
-            <a:off x="8449056" y="5532120"/>
-            <a:ext cx="2926080" cy="365760"/>
-          </a:xfrm>
-          <a:prstGeom prst="rect">
-            <a:avLst/>
-          </a:prstGeom>
-          <a:noFill/>
-          <a:ln/>
-        </p:spPr>
-        <p:txBody>
-          <a:bodyPr wrap="square" lIns="0" tIns="0" rIns="0" bIns="0" rtlCol="0" anchor="ctr"/>
-          <a:lstStyle/>
-          <a:p>
-            <a:pPr indent="0" marL="0">
-              <a:buNone/>
-            </a:pPr>
-            <a:r>
-              <a:rPr lang="en-US" sz="1250" b="1" dirty="0">
-                <a:solidFill>
-                  <a:srgbClr val="FFA101"/>
-                </a:solidFill>
-                <a:latin typeface="Montserrat" pitchFamily="34" charset="0"/>
-                <a:ea typeface="Montserrat" pitchFamily="34" charset="-122"/>
-                <a:cs typeface="Montserrat" pitchFamily="34" charset="-120"/>
-              </a:rPr>
-              <a:t>Contacter l'équipe  →</a:t>
-            </a:r>
-            <a:endParaRPr lang="en-US" sz="1250" dirty="0"/>
-          </a:p>
-        </p:txBody>
-      </p:sp>
-      <p:sp>
-        <p:nvSpPr>
-          <p:cNvPr id="19" name="Text 17"/>
           <p:cNvSpPr/>
           <p:nvPr/>
         </p:nvSpPr>
@@ -3558,13 +3553,13 @@
             <a:r>
               <a:rPr lang="en-US" sz="1100" b="1" spc="250" kern="0" dirty="0">
                 <a:solidFill>
-                  <a:srgbClr val="8047F4"/>
+                  <a:srgbClr val="FA5FB2"/>
                 </a:solidFill>
                 <a:latin typeface="JetBrains Mono" pitchFamily="34" charset="0"/>
                 <a:ea typeface="JetBrains Mono" pitchFamily="34" charset="-122"/>
                 <a:cs typeface="JetBrains Mono" pitchFamily="34" charset="-120"/>
               </a:rPr>
-              <a:t>L'ÉQUIPE</a:t>
+              <a:t>OFFRES &amp; DÉPLOIEMENT</a:t>
             </a:r>
             <a:endParaRPr lang="en-US" sz="1100" dirty="0"/>
           </a:p>
@@ -3603,7 +3598,7 @@
                 <a:ea typeface="Space Grotesk" pitchFamily="34" charset="-122"/>
                 <a:cs typeface="Space Grotesk" pitchFamily="34" charset="-120"/>
               </a:rPr>
-              <a:t>Les voix de Lyriks</a:t>
+              <a:t>Choisissez votre mode de déploiement</a:t>
             </a:r>
             <a:endParaRPr lang="en-US" sz="3000" dirty="0"/>
           </a:p>
@@ -3617,12 +3612,12 @@
         </p:nvSpPr>
         <p:spPr>
           <a:xfrm>
-            <a:off x="640080" y="2194560"/>
-            <a:ext cx="3474720" cy="2926080"/>
+            <a:off x="640080" y="1965960"/>
+            <a:ext cx="3474720" cy="4160520"/>
           </a:xfrm>
           <a:prstGeom prst="roundRect">
             <a:avLst>
-              <a:gd name="adj" fmla="val 3125"/>
+              <a:gd name="adj" fmla="val 2632"/>
             </a:avLst>
           </a:prstGeom>
           <a:solidFill>
@@ -3645,128 +3640,69 @@
       </p:sp>
       <p:sp>
         <p:nvSpPr>
-          <p:cNvPr id="5" name="Shape 3"/>
-          <p:cNvSpPr/>
-          <p:nvPr/>
-        </p:nvSpPr>
-        <p:spPr>
-          <a:xfrm>
-            <a:off x="1920240" y="2606040"/>
-            <a:ext cx="914400" cy="914400"/>
-          </a:xfrm>
-          <a:prstGeom prst="ellipse">
-            <a:avLst/>
-          </a:prstGeom>
-          <a:solidFill>
-            <a:srgbClr val="FFA101"/>
-          </a:solidFill>
-          <a:ln/>
-        </p:spPr>
-      </p:sp>
-      <p:sp>
-        <p:nvSpPr>
-          <p:cNvPr id="6" name="Text 4"/>
-          <p:cNvSpPr/>
-          <p:nvPr/>
-        </p:nvSpPr>
-        <p:spPr>
-          <a:xfrm>
-            <a:off x="1920240" y="2606040"/>
-            <a:ext cx="914400" cy="914400"/>
-          </a:xfrm>
-          <a:prstGeom prst="rect">
-            <a:avLst/>
-          </a:prstGeom>
-          <a:noFill/>
-          <a:ln/>
-        </p:spPr>
-        <p:txBody>
-          <a:bodyPr wrap="square" lIns="0" tIns="0" rIns="0" bIns="0" rtlCol="0" anchor="ctr"/>
-          <a:lstStyle/>
-          <a:p>
-            <a:pPr algn="ctr" indent="0" marL="0">
-              <a:buNone/>
-            </a:pPr>
-            <a:r>
-              <a:rPr lang="en-US" sz="2200" b="1" dirty="0">
-                <a:solidFill>
-                  <a:srgbClr val="FFFFFF"/>
+          <p:cNvPr id="5" name="Text 3"/>
+          <p:cNvSpPr/>
+          <p:nvPr/>
+        </p:nvSpPr>
+        <p:spPr>
+          <a:xfrm>
+            <a:off x="932688" y="2240280"/>
+            <a:ext cx="2926080" cy="411480"/>
+          </a:xfrm>
+          <a:prstGeom prst="rect">
+            <a:avLst/>
+          </a:prstGeom>
+          <a:noFill/>
+          <a:ln/>
+        </p:spPr>
+        <p:txBody>
+          <a:bodyPr wrap="square" lIns="0" tIns="0" rIns="0" bIns="0" rtlCol="0" anchor="ctr"/>
+          <a:lstStyle/>
+          <a:p>
+            <a:pPr indent="0" marL="0">
+              <a:buNone/>
+            </a:pPr>
+            <a:r>
+              <a:rPr lang="en-US" sz="2000" b="1" dirty="0">
+                <a:solidFill>
+                  <a:srgbClr val="BB46F5"/>
                 </a:solidFill>
                 <a:latin typeface="Space Grotesk" pitchFamily="34" charset="0"/>
                 <a:ea typeface="Space Grotesk" pitchFamily="34" charset="-122"/>
                 <a:cs typeface="Space Grotesk" pitchFamily="34" charset="-120"/>
               </a:rPr>
-              <a:t>DM</a:t>
-            </a:r>
-            <a:endParaRPr lang="en-US" sz="2200" dirty="0"/>
-          </a:p>
-        </p:txBody>
-      </p:sp>
-      <p:sp>
-        <p:nvSpPr>
-          <p:cNvPr id="7" name="Text 5"/>
-          <p:cNvSpPr/>
-          <p:nvPr/>
-        </p:nvSpPr>
-        <p:spPr>
-          <a:xfrm>
-            <a:off x="822960" y="3749040"/>
-            <a:ext cx="3108960" cy="365760"/>
-          </a:xfrm>
-          <a:prstGeom prst="rect">
-            <a:avLst/>
-          </a:prstGeom>
-          <a:noFill/>
-          <a:ln/>
-        </p:spPr>
-        <p:txBody>
-          <a:bodyPr wrap="square" lIns="0" tIns="0" rIns="0" bIns="0" rtlCol="0" anchor="ctr"/>
-          <a:lstStyle/>
-          <a:p>
-            <a:pPr algn="ctr" indent="0" marL="0">
-              <a:buNone/>
-            </a:pPr>
-            <a:r>
-              <a:rPr lang="en-US" sz="1600" b="1" dirty="0">
-                <a:solidFill>
-                  <a:srgbClr val="0A0A0A"/>
-                </a:solidFill>
-                <a:latin typeface="Space Grotesk" pitchFamily="34" charset="0"/>
-                <a:ea typeface="Space Grotesk" pitchFamily="34" charset="-122"/>
-                <a:cs typeface="Space Grotesk" pitchFamily="34" charset="-120"/>
-              </a:rPr>
-              <a:t>David Mabboux</a:t>
-            </a:r>
-            <a:endParaRPr lang="en-US" sz="1600" dirty="0"/>
-          </a:p>
-        </p:txBody>
-      </p:sp>
-      <p:sp>
-        <p:nvSpPr>
-          <p:cNvPr id="8" name="Text 6"/>
-          <p:cNvSpPr/>
-          <p:nvPr/>
-        </p:nvSpPr>
-        <p:spPr>
-          <a:xfrm>
-            <a:off x="822960" y="4160520"/>
-            <a:ext cx="3108960" cy="365760"/>
-          </a:xfrm>
-          <a:prstGeom prst="rect">
-            <a:avLst/>
-          </a:prstGeom>
-          <a:noFill/>
-          <a:ln/>
-        </p:spPr>
-        <p:txBody>
-          <a:bodyPr wrap="square" lIns="0" tIns="0" rIns="0" bIns="0" rtlCol="0" anchor="ctr"/>
-          <a:lstStyle/>
-          <a:p>
-            <a:pPr algn="ctr" indent="0" marL="0">
-              <a:buNone/>
-            </a:pPr>
-            <a:r>
-              <a:rPr lang="en-US" sz="1150" dirty="0">
+              <a:t>Community</a:t>
+            </a:r>
+            <a:endParaRPr lang="en-US" sz="2000" dirty="0"/>
+          </a:p>
+        </p:txBody>
+      </p:sp>
+      <p:sp>
+        <p:nvSpPr>
+          <p:cNvPr id="6" name="Text 4"/>
+          <p:cNvSpPr/>
+          <p:nvPr/>
+        </p:nvSpPr>
+        <p:spPr>
+          <a:xfrm>
+            <a:off x="932688" y="2670048"/>
+            <a:ext cx="2926080" cy="320040"/>
+          </a:xfrm>
+          <a:prstGeom prst="rect">
+            <a:avLst/>
+          </a:prstGeom>
+          <a:noFill/>
+          <a:ln/>
+        </p:spPr>
+        <p:txBody>
+          <a:bodyPr wrap="square" lIns="0" tIns="0" rIns="0" bIns="0" rtlCol="0" anchor="ctr"/>
+          <a:lstStyle/>
+          <a:p>
+            <a:pPr indent="0" marL="0">
+              <a:buNone/>
+            </a:pPr>
+            <a:r>
+              <a:rPr lang="en-US" sz="1050" spc="50" kern="0" dirty="0">
                 <a:solidFill>
                   <a:srgbClr val="9296A6"/>
                 </a:solidFill>
@@ -3774,9 +3710,163 @@
                 <a:ea typeface="JetBrains Mono" pitchFamily="34" charset="-122"/>
                 <a:cs typeface="JetBrains Mono" pitchFamily="34" charset="-120"/>
               </a:rPr>
-              <a:t>Business</a:t>
-            </a:r>
-            <a:endParaRPr lang="en-US" sz="1150" dirty="0"/>
+              <a:t>Open source · AGPL</a:t>
+            </a:r>
+            <a:endParaRPr lang="en-US" sz="1050" dirty="0"/>
+          </a:p>
+        </p:txBody>
+      </p:sp>
+      <p:sp>
+        <p:nvSpPr>
+          <p:cNvPr id="7" name="Text 5"/>
+          <p:cNvSpPr/>
+          <p:nvPr/>
+        </p:nvSpPr>
+        <p:spPr>
+          <a:xfrm>
+            <a:off x="932688" y="3154680"/>
+            <a:ext cx="2926080" cy="2103120"/>
+          </a:xfrm>
+          <a:prstGeom prst="rect">
+            <a:avLst/>
+          </a:prstGeom>
+          <a:noFill/>
+          <a:ln/>
+        </p:spPr>
+        <p:txBody>
+          <a:bodyPr wrap="square" lIns="0" tIns="0" rIns="0" bIns="0" rtlCol="0" anchor="ctr"/>
+          <a:lstStyle/>
+          <a:p>
+            <a:pPr marL="177800" indent="-177800">
+              <a:lnSpc>
+                <a:spcPct val="105000"/>
+              </a:lnSpc>
+              <a:spcAft>
+                <a:spcPts val="900"/>
+              </a:spcAft>
+              <a:buSzPct val="100000"/>
+              <a:buChar char="•"/>
+            </a:pPr>
+            <a:r>
+              <a:rPr lang="en-US" sz="1200" dirty="0">
+                <a:solidFill>
+                  <a:srgbClr val="1A1A1A"/>
+                </a:solidFill>
+                <a:latin typeface="Montserrat" pitchFamily="34" charset="0"/>
+                <a:ea typeface="Montserrat" pitchFamily="34" charset="-122"/>
+                <a:cs typeface="Montserrat" pitchFamily="34" charset="-120"/>
+              </a:rPr>
+              <a:t>Self-hébergé, sur vos serveurs</a:t>
+            </a:r>
+            <a:endParaRPr lang="en-US" sz="1200" dirty="0"/>
+          </a:p>
+          <a:p>
+            <a:pPr marL="177800" indent="-177800">
+              <a:lnSpc>
+                <a:spcPct val="105000"/>
+              </a:lnSpc>
+              <a:spcAft>
+                <a:spcPts val="900"/>
+              </a:spcAft>
+              <a:buSzPct val="100000"/>
+              <a:buChar char="•"/>
+            </a:pPr>
+            <a:r>
+              <a:rPr lang="en-US" sz="1200" dirty="0">
+                <a:solidFill>
+                  <a:srgbClr val="1A1A1A"/>
+                </a:solidFill>
+                <a:latin typeface="Montserrat" pitchFamily="34" charset="0"/>
+                <a:ea typeface="Montserrat" pitchFamily="34" charset="-122"/>
+                <a:cs typeface="Montserrat" pitchFamily="34" charset="-120"/>
+              </a:rPr>
+              <a:t>Modélisation produit complète</a:t>
+            </a:r>
+            <a:endParaRPr lang="en-US" sz="1200" dirty="0"/>
+          </a:p>
+          <a:p>
+            <a:pPr marL="177800" indent="-177800">
+              <a:lnSpc>
+                <a:spcPct val="105000"/>
+              </a:lnSpc>
+              <a:spcAft>
+                <a:spcPts val="900"/>
+              </a:spcAft>
+              <a:buSzPct val="100000"/>
+              <a:buChar char="•"/>
+            </a:pPr>
+            <a:r>
+              <a:rPr lang="en-US" sz="1200" dirty="0">
+                <a:solidFill>
+                  <a:srgbClr val="1A1A1A"/>
+                </a:solidFill>
+                <a:latin typeface="Montserrat" pitchFamily="34" charset="0"/>
+                <a:ea typeface="Montserrat" pitchFamily="34" charset="-122"/>
+                <a:cs typeface="Montserrat" pitchFamily="34" charset="-120"/>
+              </a:rPr>
+              <a:t>Spécifications prêtes pour l'IA</a:t>
+            </a:r>
+            <a:endParaRPr lang="en-US" sz="1200" dirty="0"/>
+          </a:p>
+          <a:p>
+            <a:pPr marL="177800" indent="-177800">
+              <a:lnSpc>
+                <a:spcPct val="105000"/>
+              </a:lnSpc>
+              <a:buSzPct val="100000"/>
+              <a:buChar char="•"/>
+            </a:pPr>
+            <a:r>
+              <a:rPr lang="en-US" sz="1200" dirty="0">
+                <a:solidFill>
+                  <a:srgbClr val="1A1A1A"/>
+                </a:solidFill>
+                <a:latin typeface="Montserrat" pitchFamily="34" charset="0"/>
+                <a:ea typeface="Montserrat" pitchFamily="34" charset="-122"/>
+                <a:cs typeface="Montserrat" pitchFamily="34" charset="-120"/>
+              </a:rPr>
+              <a:t>Contrôles de cohérence essentiels</a:t>
+            </a:r>
+            <a:endParaRPr lang="en-US" sz="1200" dirty="0"/>
+          </a:p>
+        </p:txBody>
+      </p:sp>
+      <p:sp>
+        <p:nvSpPr>
+          <p:cNvPr id="8" name="Text 6"/>
+          <p:cNvSpPr/>
+          <p:nvPr/>
+        </p:nvSpPr>
+        <p:spPr>
+          <a:xfrm>
+            <a:off x="932688" y="5532120"/>
+            <a:ext cx="2926080" cy="365760"/>
+          </a:xfrm>
+          <a:prstGeom prst="rect">
+            <a:avLst/>
+          </a:prstGeom>
+          <a:noFill/>
+          <a:ln/>
+        </p:spPr>
+        <p:txBody>
+          <a:bodyPr wrap="square" lIns="0" tIns="0" rIns="0" bIns="0" rtlCol="0" anchor="ctr"/>
+          <a:lstStyle/>
+          <a:p>
+            <a:pPr indent="0" marL="0">
+              <a:buNone/>
+            </a:pPr>
+            <a:r>
+              <a:rPr lang="en-US" sz="1250" b="1" dirty="0">
+                <a:solidFill>
+                  <a:srgbClr val="BB46F5"/>
+                </a:solidFill>
+                <a:latin typeface="Montserrat" pitchFamily="34" charset="0"/>
+                <a:ea typeface="Montserrat" pitchFamily="34" charset="-122"/>
+                <a:cs typeface="Montserrat" pitchFamily="34" charset="-120"/>
+              </a:rPr>
+              <a:t>Voir sur GitHub  →</a:t>
+            </a:r>
+            <a:endParaRPr lang="en-US" sz="1250" dirty="0"/>
           </a:p>
         </p:txBody>
       </p:sp>
@@ -3788,12 +3878,12 @@
         </p:nvSpPr>
         <p:spPr>
           <a:xfrm>
-            <a:off x="4398264" y="2194560"/>
-            <a:ext cx="3474720" cy="2926080"/>
+            <a:off x="4398264" y="1965960"/>
+            <a:ext cx="3474720" cy="4160520"/>
           </a:xfrm>
           <a:prstGeom prst="roundRect">
             <a:avLst>
-              <a:gd name="adj" fmla="val 3125"/>
+              <a:gd name="adj" fmla="val 2632"/>
             </a:avLst>
           </a:prstGeom>
           <a:solidFill>
@@ -3816,128 +3906,69 @@
       </p:sp>
       <p:sp>
         <p:nvSpPr>
-          <p:cNvPr id="10" name="Shape 8"/>
-          <p:cNvSpPr/>
-          <p:nvPr/>
-        </p:nvSpPr>
-        <p:spPr>
-          <a:xfrm>
-            <a:off x="5678424" y="2606040"/>
-            <a:ext cx="914400" cy="914400"/>
-          </a:xfrm>
-          <a:prstGeom prst="ellipse">
-            <a:avLst/>
-          </a:prstGeom>
-          <a:solidFill>
-            <a:srgbClr val="BB46F5"/>
-          </a:solidFill>
-          <a:ln/>
-        </p:spPr>
-      </p:sp>
-      <p:sp>
-        <p:nvSpPr>
-          <p:cNvPr id="11" name="Text 9"/>
-          <p:cNvSpPr/>
-          <p:nvPr/>
-        </p:nvSpPr>
-        <p:spPr>
-          <a:xfrm>
-            <a:off x="5678424" y="2606040"/>
-            <a:ext cx="914400" cy="914400"/>
-          </a:xfrm>
-          <a:prstGeom prst="rect">
-            <a:avLst/>
-          </a:prstGeom>
-          <a:noFill/>
-          <a:ln/>
-        </p:spPr>
-        <p:txBody>
-          <a:bodyPr wrap="square" lIns="0" tIns="0" rIns="0" bIns="0" rtlCol="0" anchor="ctr"/>
-          <a:lstStyle/>
-          <a:p>
-            <a:pPr algn="ctr" indent="0" marL="0">
-              <a:buNone/>
-            </a:pPr>
-            <a:r>
-              <a:rPr lang="en-US" sz="2200" b="1" dirty="0">
-                <a:solidFill>
-                  <a:srgbClr val="FFFFFF"/>
+          <p:cNvPr id="10" name="Text 8"/>
+          <p:cNvSpPr/>
+          <p:nvPr/>
+        </p:nvSpPr>
+        <p:spPr>
+          <a:xfrm>
+            <a:off x="4690872" y="2240280"/>
+            <a:ext cx="2926080" cy="411480"/>
+          </a:xfrm>
+          <a:prstGeom prst="rect">
+            <a:avLst/>
+          </a:prstGeom>
+          <a:noFill/>
+          <a:ln/>
+        </p:spPr>
+        <p:txBody>
+          <a:bodyPr wrap="square" lIns="0" tIns="0" rIns="0" bIns="0" rtlCol="0" anchor="ctr"/>
+          <a:lstStyle/>
+          <a:p>
+            <a:pPr indent="0" marL="0">
+              <a:buNone/>
+            </a:pPr>
+            <a:r>
+              <a:rPr lang="en-US" sz="2000" b="1" dirty="0">
+                <a:solidFill>
+                  <a:srgbClr val="0066FF"/>
                 </a:solidFill>
                 <a:latin typeface="Space Grotesk" pitchFamily="34" charset="0"/>
                 <a:ea typeface="Space Grotesk" pitchFamily="34" charset="-122"/>
                 <a:cs typeface="Space Grotesk" pitchFamily="34" charset="-120"/>
               </a:rPr>
-              <a:t>AB</a:t>
-            </a:r>
-            <a:endParaRPr lang="en-US" sz="2200" dirty="0"/>
-          </a:p>
-        </p:txBody>
-      </p:sp>
-      <p:sp>
-        <p:nvSpPr>
-          <p:cNvPr id="12" name="Text 10"/>
-          <p:cNvSpPr/>
-          <p:nvPr/>
-        </p:nvSpPr>
-        <p:spPr>
-          <a:xfrm>
-            <a:off x="4581144" y="3749040"/>
-            <a:ext cx="3108960" cy="365760"/>
-          </a:xfrm>
-          <a:prstGeom prst="rect">
-            <a:avLst/>
-          </a:prstGeom>
-          <a:noFill/>
-          <a:ln/>
-        </p:spPr>
-        <p:txBody>
-          <a:bodyPr wrap="square" lIns="0" tIns="0" rIns="0" bIns="0" rtlCol="0" anchor="ctr"/>
-          <a:lstStyle/>
-          <a:p>
-            <a:pPr algn="ctr" indent="0" marL="0">
-              <a:buNone/>
-            </a:pPr>
-            <a:r>
-              <a:rPr lang="en-US" sz="1600" b="1" dirty="0">
-                <a:solidFill>
-                  <a:srgbClr val="0A0A0A"/>
-                </a:solidFill>
-                <a:latin typeface="Space Grotesk" pitchFamily="34" charset="0"/>
-                <a:ea typeface="Space Grotesk" pitchFamily="34" charset="-122"/>
-                <a:cs typeface="Space Grotesk" pitchFamily="34" charset="-120"/>
-              </a:rPr>
-              <a:t>Adrien Basso Blandin</a:t>
-            </a:r>
-            <a:endParaRPr lang="en-US" sz="1600" dirty="0"/>
-          </a:p>
-        </p:txBody>
-      </p:sp>
-      <p:sp>
-        <p:nvSpPr>
-          <p:cNvPr id="13" name="Text 11"/>
-          <p:cNvSpPr/>
-          <p:nvPr/>
-        </p:nvSpPr>
-        <p:spPr>
-          <a:xfrm>
-            <a:off x="4581144" y="4160520"/>
-            <a:ext cx="3108960" cy="365760"/>
-          </a:xfrm>
-          <a:prstGeom prst="rect">
-            <a:avLst/>
-          </a:prstGeom>
-          <a:noFill/>
-          <a:ln/>
-        </p:spPr>
-        <p:txBody>
-          <a:bodyPr wrap="square" lIns="0" tIns="0" rIns="0" bIns="0" rtlCol="0" anchor="ctr"/>
-          <a:lstStyle/>
-          <a:p>
-            <a:pPr algn="ctr" indent="0" marL="0">
-              <a:buNone/>
-            </a:pPr>
-            <a:r>
-              <a:rPr lang="en-US" sz="1150" dirty="0">
+              <a:t>Enterprise</a:t>
+            </a:r>
+            <a:endParaRPr lang="en-US" sz="2000" dirty="0"/>
+          </a:p>
+        </p:txBody>
+      </p:sp>
+      <p:sp>
+        <p:nvSpPr>
+          <p:cNvPr id="11" name="Text 9"/>
+          <p:cNvSpPr/>
+          <p:nvPr/>
+        </p:nvSpPr>
+        <p:spPr>
+          <a:xfrm>
+            <a:off x="4690872" y="2670048"/>
+            <a:ext cx="2926080" cy="320040"/>
+          </a:xfrm>
+          <a:prstGeom prst="rect">
+            <a:avLst/>
+          </a:prstGeom>
+          <a:noFill/>
+          <a:ln/>
+        </p:spPr>
+        <p:txBody>
+          <a:bodyPr wrap="square" lIns="0" tIns="0" rIns="0" bIns="0" rtlCol="0" anchor="ctr"/>
+          <a:lstStyle/>
+          <a:p>
+            <a:pPr indent="0" marL="0">
+              <a:buNone/>
+            </a:pPr>
+            <a:r>
+              <a:rPr lang="en-US" sz="1050" spc="50" kern="0" dirty="0">
                 <a:solidFill>
                   <a:srgbClr val="9296A6"/>
                 </a:solidFill>
@@ -3945,9 +3976,163 @@
                 <a:ea typeface="JetBrains Mono" pitchFamily="34" charset="-122"/>
                 <a:cs typeface="JetBrains Mono" pitchFamily="34" charset="-120"/>
               </a:rPr>
-              <a:t>Cohérence</a:t>
-            </a:r>
-            <a:endParaRPr lang="en-US" sz="1150" dirty="0"/>
+              <a:t>Licence annuelle · self-service</a:t>
+            </a:r>
+            <a:endParaRPr lang="en-US" sz="1050" dirty="0"/>
+          </a:p>
+        </p:txBody>
+      </p:sp>
+      <p:sp>
+        <p:nvSpPr>
+          <p:cNvPr id="12" name="Text 10"/>
+          <p:cNvSpPr/>
+          <p:nvPr/>
+        </p:nvSpPr>
+        <p:spPr>
+          <a:xfrm>
+            <a:off x="4690872" y="3154680"/>
+            <a:ext cx="2926080" cy="2103120"/>
+          </a:xfrm>
+          <a:prstGeom prst="rect">
+            <a:avLst/>
+          </a:prstGeom>
+          <a:noFill/>
+          <a:ln/>
+        </p:spPr>
+        <p:txBody>
+          <a:bodyPr wrap="square" lIns="0" tIns="0" rIns="0" bIns="0" rtlCol="0" anchor="ctr"/>
+          <a:lstStyle/>
+          <a:p>
+            <a:pPr marL="177800" indent="-177800">
+              <a:lnSpc>
+                <a:spcPct val="105000"/>
+              </a:lnSpc>
+              <a:spcAft>
+                <a:spcPts val="900"/>
+              </a:spcAft>
+              <a:buSzPct val="100000"/>
+              <a:buChar char="•"/>
+            </a:pPr>
+            <a:r>
+              <a:rPr lang="en-US" sz="1200" dirty="0">
+                <a:solidFill>
+                  <a:srgbClr val="1A1A1A"/>
+                </a:solidFill>
+                <a:latin typeface="Montserrat" pitchFamily="34" charset="0"/>
+                <a:ea typeface="Montserrat" pitchFamily="34" charset="-122"/>
+                <a:cs typeface="Montserrat" pitchFamily="34" charset="-120"/>
+              </a:rPr>
+              <a:t>Équipes multi-utilisateurs</a:t>
+            </a:r>
+            <a:endParaRPr lang="en-US" sz="1200" dirty="0"/>
+          </a:p>
+          <a:p>
+            <a:pPr marL="177800" indent="-177800">
+              <a:lnSpc>
+                <a:spcPct val="105000"/>
+              </a:lnSpc>
+              <a:spcAft>
+                <a:spcPts val="900"/>
+              </a:spcAft>
+              <a:buSzPct val="100000"/>
+              <a:buChar char="•"/>
+            </a:pPr>
+            <a:r>
+              <a:rPr lang="en-US" sz="1200" dirty="0">
+                <a:solidFill>
+                  <a:srgbClr val="1A1A1A"/>
+                </a:solidFill>
+                <a:latin typeface="Montserrat" pitchFamily="34" charset="0"/>
+                <a:ea typeface="Montserrat" pitchFamily="34" charset="-122"/>
+                <a:cs typeface="Montserrat" pitchFamily="34" charset="-120"/>
+              </a:rPr>
+              <a:t>Gestion des droits &amp; rôles</a:t>
+            </a:r>
+            <a:endParaRPr lang="en-US" sz="1200" dirty="0"/>
+          </a:p>
+          <a:p>
+            <a:pPr marL="177800" indent="-177800">
+              <a:lnSpc>
+                <a:spcPct val="105000"/>
+              </a:lnSpc>
+              <a:spcAft>
+                <a:spcPts val="900"/>
+              </a:spcAft>
+              <a:buSzPct val="100000"/>
+              <a:buChar char="•"/>
+            </a:pPr>
+            <a:r>
+              <a:rPr lang="en-US" sz="1200" dirty="0">
+                <a:solidFill>
+                  <a:srgbClr val="1A1A1A"/>
+                </a:solidFill>
+                <a:latin typeface="Montserrat" pitchFamily="34" charset="0"/>
+                <a:ea typeface="Montserrat" pitchFamily="34" charset="-122"/>
+                <a:cs typeface="Montserrat" pitchFamily="34" charset="-120"/>
+              </a:rPr>
+              <a:t>Collaboration en temps réel</a:t>
+            </a:r>
+            <a:endParaRPr lang="en-US" sz="1200" dirty="0"/>
+          </a:p>
+          <a:p>
+            <a:pPr marL="177800" indent="-177800">
+              <a:lnSpc>
+                <a:spcPct val="105000"/>
+              </a:lnSpc>
+              <a:buSzPct val="100000"/>
+              <a:buChar char="•"/>
+            </a:pPr>
+            <a:r>
+              <a:rPr lang="en-US" sz="1200" dirty="0">
+                <a:solidFill>
+                  <a:srgbClr val="1A1A1A"/>
+                </a:solidFill>
+                <a:latin typeface="Montserrat" pitchFamily="34" charset="0"/>
+                <a:ea typeface="Montserrat" pitchFamily="34" charset="-122"/>
+                <a:cs typeface="Montserrat" pitchFamily="34" charset="-120"/>
+              </a:rPr>
+              <a:t>Vérification après implémentation</a:t>
+            </a:r>
+            <a:endParaRPr lang="en-US" sz="1200" dirty="0"/>
+          </a:p>
+        </p:txBody>
+      </p:sp>
+      <p:sp>
+        <p:nvSpPr>
+          <p:cNvPr id="13" name="Text 11"/>
+          <p:cNvSpPr/>
+          <p:nvPr/>
+        </p:nvSpPr>
+        <p:spPr>
+          <a:xfrm>
+            <a:off x="4690872" y="5532120"/>
+            <a:ext cx="2926080" cy="365760"/>
+          </a:xfrm>
+          <a:prstGeom prst="rect">
+            <a:avLst/>
+          </a:prstGeom>
+          <a:noFill/>
+          <a:ln/>
+        </p:spPr>
+        <p:txBody>
+          <a:bodyPr wrap="square" lIns="0" tIns="0" rIns="0" bIns="0" rtlCol="0" anchor="ctr"/>
+          <a:lstStyle/>
+          <a:p>
+            <a:pPr indent="0" marL="0">
+              <a:buNone/>
+            </a:pPr>
+            <a:r>
+              <a:rPr lang="en-US" sz="1250" b="1" dirty="0">
+                <a:solidFill>
+                  <a:srgbClr val="0066FF"/>
+                </a:solidFill>
+                <a:latin typeface="Montserrat" pitchFamily="34" charset="0"/>
+                <a:ea typeface="Montserrat" pitchFamily="34" charset="-122"/>
+                <a:cs typeface="Montserrat" pitchFamily="34" charset="-120"/>
+              </a:rPr>
+              <a:t>Demander un devis  →</a:t>
+            </a:r>
+            <a:endParaRPr lang="en-US" sz="1250" dirty="0"/>
           </a:p>
         </p:txBody>
       </p:sp>
@@ -3959,12 +4144,12 @@
         </p:nvSpPr>
         <p:spPr>
           <a:xfrm>
-            <a:off x="8156448" y="2194560"/>
-            <a:ext cx="3474720" cy="2926080"/>
+            <a:off x="8156448" y="1965960"/>
+            <a:ext cx="3474720" cy="4160520"/>
           </a:xfrm>
           <a:prstGeom prst="roundRect">
             <a:avLst>
-              <a:gd name="adj" fmla="val 3125"/>
+              <a:gd name="adj" fmla="val 2632"/>
             </a:avLst>
           </a:prstGeom>
           <a:solidFill>
@@ -3987,128 +4172,69 @@
       </p:sp>
       <p:sp>
         <p:nvSpPr>
-          <p:cNvPr id="15" name="Shape 13"/>
-          <p:cNvSpPr/>
-          <p:nvPr/>
-        </p:nvSpPr>
-        <p:spPr>
-          <a:xfrm>
-            <a:off x="9436608" y="2606040"/>
-            <a:ext cx="914400" cy="914400"/>
-          </a:xfrm>
-          <a:prstGeom prst="ellipse">
-            <a:avLst/>
-          </a:prstGeom>
-          <a:solidFill>
-            <a:srgbClr val="0066FF"/>
-          </a:solidFill>
-          <a:ln/>
-        </p:spPr>
-      </p:sp>
-      <p:sp>
-        <p:nvSpPr>
-          <p:cNvPr id="16" name="Text 14"/>
-          <p:cNvSpPr/>
-          <p:nvPr/>
-        </p:nvSpPr>
-        <p:spPr>
-          <a:xfrm>
-            <a:off x="9436608" y="2606040"/>
-            <a:ext cx="914400" cy="914400"/>
-          </a:xfrm>
-          <a:prstGeom prst="rect">
-            <a:avLst/>
-          </a:prstGeom>
-          <a:noFill/>
-          <a:ln/>
-        </p:spPr>
-        <p:txBody>
-          <a:bodyPr wrap="square" lIns="0" tIns="0" rIns="0" bIns="0" rtlCol="0" anchor="ctr"/>
-          <a:lstStyle/>
-          <a:p>
-            <a:pPr algn="ctr" indent="0" marL="0">
-              <a:buNone/>
-            </a:pPr>
-            <a:r>
-              <a:rPr lang="en-US" sz="2200" b="1" dirty="0">
-                <a:solidFill>
-                  <a:srgbClr val="FFFFFF"/>
+          <p:cNvPr id="15" name="Text 13"/>
+          <p:cNvSpPr/>
+          <p:nvPr/>
+        </p:nvSpPr>
+        <p:spPr>
+          <a:xfrm>
+            <a:off x="8449056" y="2240280"/>
+            <a:ext cx="2926080" cy="411480"/>
+          </a:xfrm>
+          <a:prstGeom prst="rect">
+            <a:avLst/>
+          </a:prstGeom>
+          <a:noFill/>
+          <a:ln/>
+        </p:spPr>
+        <p:txBody>
+          <a:bodyPr wrap="square" lIns="0" tIns="0" rIns="0" bIns="0" rtlCol="0" anchor="ctr"/>
+          <a:lstStyle/>
+          <a:p>
+            <a:pPr indent="0" marL="0">
+              <a:buNone/>
+            </a:pPr>
+            <a:r>
+              <a:rPr lang="en-US" sz="2000" b="1" dirty="0">
+                <a:solidFill>
+                  <a:srgbClr val="FFA101"/>
                 </a:solidFill>
                 <a:latin typeface="Space Grotesk" pitchFamily="34" charset="0"/>
                 <a:ea typeface="Space Grotesk" pitchFamily="34" charset="-122"/>
                 <a:cs typeface="Space Grotesk" pitchFamily="34" charset="-120"/>
               </a:rPr>
-              <a:t>AC</a:t>
-            </a:r>
-            <a:endParaRPr lang="en-US" sz="2200" dirty="0"/>
-          </a:p>
-        </p:txBody>
-      </p:sp>
-      <p:sp>
-        <p:nvSpPr>
-          <p:cNvPr id="17" name="Text 15"/>
-          <p:cNvSpPr/>
-          <p:nvPr/>
-        </p:nvSpPr>
-        <p:spPr>
-          <a:xfrm>
-            <a:off x="8339328" y="3749040"/>
-            <a:ext cx="3108960" cy="365760"/>
-          </a:xfrm>
-          <a:prstGeom prst="rect">
-            <a:avLst/>
-          </a:prstGeom>
-          <a:noFill/>
-          <a:ln/>
-        </p:spPr>
-        <p:txBody>
-          <a:bodyPr wrap="square" lIns="0" tIns="0" rIns="0" bIns="0" rtlCol="0" anchor="ctr"/>
-          <a:lstStyle/>
-          <a:p>
-            <a:pPr algn="ctr" indent="0" marL="0">
-              <a:buNone/>
-            </a:pPr>
-            <a:r>
-              <a:rPr lang="en-US" sz="1600" b="1" dirty="0">
-                <a:solidFill>
-                  <a:srgbClr val="0A0A0A"/>
-                </a:solidFill>
-                <a:latin typeface="Space Grotesk" pitchFamily="34" charset="0"/>
-                <a:ea typeface="Space Grotesk" pitchFamily="34" charset="-122"/>
-                <a:cs typeface="Space Grotesk" pitchFamily="34" charset="-120"/>
-              </a:rPr>
-              <a:t>Adrien Charles</a:t>
-            </a:r>
-            <a:endParaRPr lang="en-US" sz="1600" dirty="0"/>
-          </a:p>
-        </p:txBody>
-      </p:sp>
-      <p:sp>
-        <p:nvSpPr>
-          <p:cNvPr id="18" name="Text 16"/>
-          <p:cNvSpPr/>
-          <p:nvPr/>
-        </p:nvSpPr>
-        <p:spPr>
-          <a:xfrm>
-            <a:off x="8339328" y="4160520"/>
-            <a:ext cx="3108960" cy="365760"/>
-          </a:xfrm>
-          <a:prstGeom prst="rect">
-            <a:avLst/>
-          </a:prstGeom>
-          <a:noFill/>
-          <a:ln/>
-        </p:spPr>
-        <p:txBody>
-          <a:bodyPr wrap="square" lIns="0" tIns="0" rIns="0" bIns="0" rtlCol="0" anchor="ctr"/>
-          <a:lstStyle/>
-          <a:p>
-            <a:pPr algn="ctr" indent="0" marL="0">
-              <a:buNone/>
-            </a:pPr>
-            <a:r>
-              <a:rPr lang="en-US" sz="1150" dirty="0">
+              <a:t>Managé</a:t>
+            </a:r>
+            <a:endParaRPr lang="en-US" sz="2000" dirty="0"/>
+          </a:p>
+        </p:txBody>
+      </p:sp>
+      <p:sp>
+        <p:nvSpPr>
+          <p:cNvPr id="16" name="Text 14"/>
+          <p:cNvSpPr/>
+          <p:nvPr/>
+        </p:nvSpPr>
+        <p:spPr>
+          <a:xfrm>
+            <a:off x="8449056" y="2670048"/>
+            <a:ext cx="2926080" cy="320040"/>
+          </a:xfrm>
+          <a:prstGeom prst="rect">
+            <a:avLst/>
+          </a:prstGeom>
+          <a:noFill/>
+          <a:ln/>
+        </p:spPr>
+        <p:txBody>
+          <a:bodyPr wrap="square" lIns="0" tIns="0" rIns="0" bIns="0" rtlCol="0" anchor="ctr"/>
+          <a:lstStyle/>
+          <a:p>
+            <a:pPr indent="0" marL="0">
+              <a:buNone/>
+            </a:pPr>
+            <a:r>
+              <a:rPr lang="en-US" sz="1050" spc="50" kern="0" dirty="0">
                 <a:solidFill>
                   <a:srgbClr val="9296A6"/>
                 </a:solidFill>
@@ -4116,9 +4242,163 @@
                 <a:ea typeface="JetBrains Mono" pitchFamily="34" charset="-122"/>
                 <a:cs typeface="JetBrains Mono" pitchFamily="34" charset="-120"/>
               </a:rPr>
-              <a:t>Produit</a:t>
-            </a:r>
-            <a:endParaRPr lang="en-US" sz="1150" dirty="0"/>
+              <a:t>Hébergé &amp; opéré par Lyriks</a:t>
+            </a:r>
+            <a:endParaRPr lang="en-US" sz="1050" dirty="0"/>
+          </a:p>
+        </p:txBody>
+      </p:sp>
+      <p:sp>
+        <p:nvSpPr>
+          <p:cNvPr id="17" name="Text 15"/>
+          <p:cNvSpPr/>
+          <p:nvPr/>
+        </p:nvSpPr>
+        <p:spPr>
+          <a:xfrm>
+            <a:off x="8449056" y="3154680"/>
+            <a:ext cx="2926080" cy="2103120"/>
+          </a:xfrm>
+          <a:prstGeom prst="rect">
+            <a:avLst/>
+          </a:prstGeom>
+          <a:noFill/>
+          <a:ln/>
+        </p:spPr>
+        <p:txBody>
+          <a:bodyPr wrap="square" lIns="0" tIns="0" rIns="0" bIns="0" rtlCol="0" anchor="ctr"/>
+          <a:lstStyle/>
+          <a:p>
+            <a:pPr marL="177800" indent="-177800">
+              <a:lnSpc>
+                <a:spcPct val="105000"/>
+              </a:lnSpc>
+              <a:spcAft>
+                <a:spcPts val="900"/>
+              </a:spcAft>
+              <a:buSzPct val="100000"/>
+              <a:buChar char="•"/>
+            </a:pPr>
+            <a:r>
+              <a:rPr lang="en-US" sz="1200" dirty="0">
+                <a:solidFill>
+                  <a:srgbClr val="1A1A1A"/>
+                </a:solidFill>
+                <a:latin typeface="Montserrat" pitchFamily="34" charset="0"/>
+                <a:ea typeface="Montserrat" pitchFamily="34" charset="-122"/>
+                <a:cs typeface="Montserrat" pitchFamily="34" charset="-120"/>
+              </a:rPr>
+              <a:t>Infogérance complète &amp; SLA</a:t>
+            </a:r>
+            <a:endParaRPr lang="en-US" sz="1200" dirty="0"/>
+          </a:p>
+          <a:p>
+            <a:pPr marL="177800" indent="-177800">
+              <a:lnSpc>
+                <a:spcPct val="105000"/>
+              </a:lnSpc>
+              <a:spcAft>
+                <a:spcPts val="900"/>
+              </a:spcAft>
+              <a:buSzPct val="100000"/>
+              <a:buChar char="•"/>
+            </a:pPr>
+            <a:r>
+              <a:rPr lang="en-US" sz="1200" dirty="0">
+                <a:solidFill>
+                  <a:srgbClr val="1A1A1A"/>
+                </a:solidFill>
+                <a:latin typeface="Montserrat" pitchFamily="34" charset="0"/>
+                <a:ea typeface="Montserrat" pitchFamily="34" charset="-122"/>
+                <a:cs typeface="Montserrat" pitchFamily="34" charset="-120"/>
+              </a:rPr>
+              <a:t>Supervision avancée des usages IA</a:t>
+            </a:r>
+            <a:endParaRPr lang="en-US" sz="1200" dirty="0"/>
+          </a:p>
+          <a:p>
+            <a:pPr marL="177800" indent="-177800">
+              <a:lnSpc>
+                <a:spcPct val="105000"/>
+              </a:lnSpc>
+              <a:spcAft>
+                <a:spcPts val="900"/>
+              </a:spcAft>
+              <a:buSzPct val="100000"/>
+              <a:buChar char="•"/>
+            </a:pPr>
+            <a:r>
+              <a:rPr lang="en-US" sz="1200" dirty="0">
+                <a:solidFill>
+                  <a:srgbClr val="1A1A1A"/>
+                </a:solidFill>
+                <a:latin typeface="Montserrat" pitchFamily="34" charset="0"/>
+                <a:ea typeface="Montserrat" pitchFamily="34" charset="-122"/>
+                <a:cs typeface="Montserrat" pitchFamily="34" charset="-120"/>
+              </a:rPr>
+              <a:t>SSO &amp; sécurité avancée</a:t>
+            </a:r>
+            <a:endParaRPr lang="en-US" sz="1200" dirty="0"/>
+          </a:p>
+          <a:p>
+            <a:pPr marL="177800" indent="-177800">
+              <a:lnSpc>
+                <a:spcPct val="105000"/>
+              </a:lnSpc>
+              <a:buSzPct val="100000"/>
+              <a:buChar char="•"/>
+            </a:pPr>
+            <a:r>
+              <a:rPr lang="en-US" sz="1200" dirty="0">
+                <a:solidFill>
+                  <a:srgbClr val="1A1A1A"/>
+                </a:solidFill>
+                <a:latin typeface="Montserrat" pitchFamily="34" charset="0"/>
+                <a:ea typeface="Montserrat" pitchFamily="34" charset="-122"/>
+                <a:cs typeface="Montserrat" pitchFamily="34" charset="-120"/>
+              </a:rPr>
+              <a:t>Accompagnement dédié</a:t>
+            </a:r>
+            <a:endParaRPr lang="en-US" sz="1200" dirty="0"/>
+          </a:p>
+        </p:txBody>
+      </p:sp>
+      <p:sp>
+        <p:nvSpPr>
+          <p:cNvPr id="18" name="Text 16"/>
+          <p:cNvSpPr/>
+          <p:nvPr/>
+        </p:nvSpPr>
+        <p:spPr>
+          <a:xfrm>
+            <a:off x="8449056" y="5532120"/>
+            <a:ext cx="2926080" cy="365760"/>
+          </a:xfrm>
+          <a:prstGeom prst="rect">
+            <a:avLst/>
+          </a:prstGeom>
+          <a:noFill/>
+          <a:ln/>
+        </p:spPr>
+        <p:txBody>
+          <a:bodyPr wrap="square" lIns="0" tIns="0" rIns="0" bIns="0" rtlCol="0" anchor="ctr"/>
+          <a:lstStyle/>
+          <a:p>
+            <a:pPr indent="0" marL="0">
+              <a:buNone/>
+            </a:pPr>
+            <a:r>
+              <a:rPr lang="en-US" sz="1250" b="1" dirty="0">
+                <a:solidFill>
+                  <a:srgbClr val="FFA101"/>
+                </a:solidFill>
+                <a:latin typeface="Montserrat" pitchFamily="34" charset="0"/>
+                <a:ea typeface="Montserrat" pitchFamily="34" charset="-122"/>
+                <a:cs typeface="Montserrat" pitchFamily="34" charset="-120"/>
+              </a:rPr>
+              <a:t>Contacter l'équipe  →</a:t>
+            </a:r>
+            <a:endParaRPr lang="en-US" sz="1250" dirty="0"/>
           </a:p>
         </p:txBody>
       </p:sp>
@@ -4172,6 +4452,668 @@
 <file path=ppt/slides/slide13.xml><?xml version="1.0" encoding="utf-8"?>
 <p:sld xmlns:a="http://schemas.openxmlformats.org/drawingml/2006/main" xmlns:r="http://schemas.openxmlformats.org/officeDocument/2006/relationships" xmlns:p="http://schemas.openxmlformats.org/presentationml/2006/main">
   <p:cSld name="Slide 13">
+    <p:bg>
+      <p:bgPr>
+        <a:solidFill>
+          <a:srgbClr val="FFFFFF"/>
+        </a:solidFill>
+      </p:bgPr>
+    </p:bg>
+    <p:spTree>
+      <p:nvGrpSpPr>
+        <p:cNvPr id="1" name=""/>
+        <p:cNvGrpSpPr/>
+        <p:nvPr/>
+      </p:nvGrpSpPr>
+      <p:grpSpPr>
+        <a:xfrm>
+          <a:off x="0" y="0"/>
+          <a:ext cx="0" cy="0"/>
+          <a:chOff x="0" y="0"/>
+          <a:chExt cx="0" cy="0"/>
+        </a:xfrm>
+      </p:grpSpPr>
+      <p:sp>
+        <p:nvSpPr>
+          <p:cNvPr id="2" name="Text 0"/>
+          <p:cNvSpPr/>
+          <p:nvPr/>
+        </p:nvSpPr>
+        <p:spPr>
+          <a:xfrm>
+            <a:off x="640080" y="640080"/>
+            <a:ext cx="8229600" cy="274320"/>
+          </a:xfrm>
+          <a:prstGeom prst="rect">
+            <a:avLst/>
+          </a:prstGeom>
+          <a:noFill/>
+          <a:ln/>
+        </p:spPr>
+        <p:txBody>
+          <a:bodyPr wrap="square" lIns="0" tIns="0" rIns="0" bIns="0" rtlCol="0" anchor="ctr"/>
+          <a:lstStyle/>
+          <a:p>
+            <a:pPr indent="0" marL="0">
+              <a:buNone/>
+            </a:pPr>
+            <a:r>
+              <a:rPr lang="en-US" sz="1100" b="1" spc="250" kern="0" dirty="0">
+                <a:solidFill>
+                  <a:srgbClr val="8047F4"/>
+                </a:solidFill>
+                <a:latin typeface="JetBrains Mono" pitchFamily="34" charset="0"/>
+                <a:ea typeface="JetBrains Mono" pitchFamily="34" charset="-122"/>
+                <a:cs typeface="JetBrains Mono" pitchFamily="34" charset="-120"/>
+              </a:rPr>
+              <a:t>L'ÉQUIPE</a:t>
+            </a:r>
+            <a:endParaRPr lang="en-US" sz="1100" dirty="0"/>
+          </a:p>
+        </p:txBody>
+      </p:sp>
+      <p:sp>
+        <p:nvSpPr>
+          <p:cNvPr id="3" name="Text 1"/>
+          <p:cNvSpPr/>
+          <p:nvPr/>
+        </p:nvSpPr>
+        <p:spPr>
+          <a:xfrm>
+            <a:off x="640080" y="960120"/>
+            <a:ext cx="10058400" cy="822960"/>
+          </a:xfrm>
+          <a:prstGeom prst="rect">
+            <a:avLst/>
+          </a:prstGeom>
+          <a:noFill/>
+          <a:ln/>
+        </p:spPr>
+        <p:txBody>
+          <a:bodyPr wrap="square" lIns="0" tIns="0" rIns="0" bIns="0" rtlCol="0" anchor="ctr"/>
+          <a:lstStyle/>
+          <a:p>
+            <a:pPr indent="0" marL="0">
+              <a:buNone/>
+            </a:pPr>
+            <a:r>
+              <a:rPr lang="en-US" sz="3000" b="1" dirty="0">
+                <a:solidFill>
+                  <a:srgbClr val="0A0A0A"/>
+                </a:solidFill>
+                <a:latin typeface="Space Grotesk" pitchFamily="34" charset="0"/>
+                <a:ea typeface="Space Grotesk" pitchFamily="34" charset="-122"/>
+                <a:cs typeface="Space Grotesk" pitchFamily="34" charset="-120"/>
+              </a:rPr>
+              <a:t>Les voix de Lyriks</a:t>
+            </a:r>
+            <a:endParaRPr lang="en-US" sz="3000" dirty="0"/>
+          </a:p>
+        </p:txBody>
+      </p:sp>
+      <p:sp>
+        <p:nvSpPr>
+          <p:cNvPr id="4" name="Shape 2"/>
+          <p:cNvSpPr/>
+          <p:nvPr/>
+        </p:nvSpPr>
+        <p:spPr>
+          <a:xfrm>
+            <a:off x="640080" y="2194560"/>
+            <a:ext cx="3474720" cy="2926080"/>
+          </a:xfrm>
+          <a:prstGeom prst="roundRect">
+            <a:avLst>
+              <a:gd name="adj" fmla="val 3125"/>
+            </a:avLst>
+          </a:prstGeom>
+          <a:solidFill>
+            <a:srgbClr val="FFFFFF"/>
+          </a:solidFill>
+          <a:ln w="12700">
+            <a:solidFill>
+              <a:srgbClr val="E8E8EE"/>
+            </a:solidFill>
+            <a:prstDash val="solid"/>
+          </a:ln>
+          <a:effectLst>
+            <a:outerShdw sx="100000" sy="100000" kx="0" ky="0" algn="bl" rotWithShape="0" blurRad="114300" dist="38100" dir="5400000">
+              <a:srgbClr val="10122A">
+                <a:alpha val="12000"/>
+              </a:srgbClr>
+            </a:outerShdw>
+          </a:effectLst>
+        </p:spPr>
+      </p:sp>
+      <p:sp>
+        <p:nvSpPr>
+          <p:cNvPr id="5" name="Shape 3"/>
+          <p:cNvSpPr/>
+          <p:nvPr/>
+        </p:nvSpPr>
+        <p:spPr>
+          <a:xfrm>
+            <a:off x="1920240" y="2606040"/>
+            <a:ext cx="914400" cy="914400"/>
+          </a:xfrm>
+          <a:prstGeom prst="ellipse">
+            <a:avLst/>
+          </a:prstGeom>
+          <a:solidFill>
+            <a:srgbClr val="FFA101"/>
+          </a:solidFill>
+          <a:ln/>
+        </p:spPr>
+      </p:sp>
+      <p:sp>
+        <p:nvSpPr>
+          <p:cNvPr id="6" name="Text 4"/>
+          <p:cNvSpPr/>
+          <p:nvPr/>
+        </p:nvSpPr>
+        <p:spPr>
+          <a:xfrm>
+            <a:off x="1920240" y="2606040"/>
+            <a:ext cx="914400" cy="914400"/>
+          </a:xfrm>
+          <a:prstGeom prst="rect">
+            <a:avLst/>
+          </a:prstGeom>
+          <a:noFill/>
+          <a:ln/>
+        </p:spPr>
+        <p:txBody>
+          <a:bodyPr wrap="square" lIns="0" tIns="0" rIns="0" bIns="0" rtlCol="0" anchor="ctr"/>
+          <a:lstStyle/>
+          <a:p>
+            <a:pPr algn="ctr" indent="0" marL="0">
+              <a:buNone/>
+            </a:pPr>
+            <a:r>
+              <a:rPr lang="en-US" sz="2200" b="1" dirty="0">
+                <a:solidFill>
+                  <a:srgbClr val="FFFFFF"/>
+                </a:solidFill>
+                <a:latin typeface="Space Grotesk" pitchFamily="34" charset="0"/>
+                <a:ea typeface="Space Grotesk" pitchFamily="34" charset="-122"/>
+                <a:cs typeface="Space Grotesk" pitchFamily="34" charset="-120"/>
+              </a:rPr>
+              <a:t>DM</a:t>
+            </a:r>
+            <a:endParaRPr lang="en-US" sz="2200" dirty="0"/>
+          </a:p>
+        </p:txBody>
+      </p:sp>
+      <p:sp>
+        <p:nvSpPr>
+          <p:cNvPr id="7" name="Text 5"/>
+          <p:cNvSpPr/>
+          <p:nvPr/>
+        </p:nvSpPr>
+        <p:spPr>
+          <a:xfrm>
+            <a:off x="822960" y="3749040"/>
+            <a:ext cx="3108960" cy="365760"/>
+          </a:xfrm>
+          <a:prstGeom prst="rect">
+            <a:avLst/>
+          </a:prstGeom>
+          <a:noFill/>
+          <a:ln/>
+        </p:spPr>
+        <p:txBody>
+          <a:bodyPr wrap="square" lIns="0" tIns="0" rIns="0" bIns="0" rtlCol="0" anchor="ctr"/>
+          <a:lstStyle/>
+          <a:p>
+            <a:pPr algn="ctr" indent="0" marL="0">
+              <a:buNone/>
+            </a:pPr>
+            <a:r>
+              <a:rPr lang="en-US" sz="1600" b="1" dirty="0">
+                <a:solidFill>
+                  <a:srgbClr val="0A0A0A"/>
+                </a:solidFill>
+                <a:latin typeface="Space Grotesk" pitchFamily="34" charset="0"/>
+                <a:ea typeface="Space Grotesk" pitchFamily="34" charset="-122"/>
+                <a:cs typeface="Space Grotesk" pitchFamily="34" charset="-120"/>
+              </a:rPr>
+              <a:t>David Mabboux</a:t>
+            </a:r>
+            <a:endParaRPr lang="en-US" sz="1600" dirty="0"/>
+          </a:p>
+        </p:txBody>
+      </p:sp>
+      <p:sp>
+        <p:nvSpPr>
+          <p:cNvPr id="8" name="Text 6"/>
+          <p:cNvSpPr/>
+          <p:nvPr/>
+        </p:nvSpPr>
+        <p:spPr>
+          <a:xfrm>
+            <a:off x="822960" y="4160520"/>
+            <a:ext cx="3108960" cy="365760"/>
+          </a:xfrm>
+          <a:prstGeom prst="rect">
+            <a:avLst/>
+          </a:prstGeom>
+          <a:noFill/>
+          <a:ln/>
+        </p:spPr>
+        <p:txBody>
+          <a:bodyPr wrap="square" lIns="0" tIns="0" rIns="0" bIns="0" rtlCol="0" anchor="ctr"/>
+          <a:lstStyle/>
+          <a:p>
+            <a:pPr algn="ctr" indent="0" marL="0">
+              <a:buNone/>
+            </a:pPr>
+            <a:r>
+              <a:rPr lang="en-US" sz="1150" dirty="0">
+                <a:solidFill>
+                  <a:srgbClr val="9296A6"/>
+                </a:solidFill>
+                <a:latin typeface="JetBrains Mono" pitchFamily="34" charset="0"/>
+                <a:ea typeface="JetBrains Mono" pitchFamily="34" charset="-122"/>
+                <a:cs typeface="JetBrains Mono" pitchFamily="34" charset="-120"/>
+              </a:rPr>
+              <a:t>Business</a:t>
+            </a:r>
+            <a:endParaRPr lang="en-US" sz="1150" dirty="0"/>
+          </a:p>
+        </p:txBody>
+      </p:sp>
+      <p:sp>
+        <p:nvSpPr>
+          <p:cNvPr id="9" name="Shape 7"/>
+          <p:cNvSpPr/>
+          <p:nvPr/>
+        </p:nvSpPr>
+        <p:spPr>
+          <a:xfrm>
+            <a:off x="4398264" y="2194560"/>
+            <a:ext cx="3474720" cy="2926080"/>
+          </a:xfrm>
+          <a:prstGeom prst="roundRect">
+            <a:avLst>
+              <a:gd name="adj" fmla="val 3125"/>
+            </a:avLst>
+          </a:prstGeom>
+          <a:solidFill>
+            <a:srgbClr val="FFFFFF"/>
+          </a:solidFill>
+          <a:ln w="12700">
+            <a:solidFill>
+              <a:srgbClr val="E8E8EE"/>
+            </a:solidFill>
+            <a:prstDash val="solid"/>
+          </a:ln>
+          <a:effectLst>
+            <a:outerShdw sx="100000" sy="100000" kx="0" ky="0" algn="bl" rotWithShape="0" blurRad="114300" dist="38100" dir="5400000">
+              <a:srgbClr val="10122A">
+                <a:alpha val="12000"/>
+              </a:srgbClr>
+            </a:outerShdw>
+          </a:effectLst>
+        </p:spPr>
+      </p:sp>
+      <p:sp>
+        <p:nvSpPr>
+          <p:cNvPr id="10" name="Shape 8"/>
+          <p:cNvSpPr/>
+          <p:nvPr/>
+        </p:nvSpPr>
+        <p:spPr>
+          <a:xfrm>
+            <a:off x="5678424" y="2606040"/>
+            <a:ext cx="914400" cy="914400"/>
+          </a:xfrm>
+          <a:prstGeom prst="ellipse">
+            <a:avLst/>
+          </a:prstGeom>
+          <a:solidFill>
+            <a:srgbClr val="BB46F5"/>
+          </a:solidFill>
+          <a:ln/>
+        </p:spPr>
+      </p:sp>
+      <p:sp>
+        <p:nvSpPr>
+          <p:cNvPr id="11" name="Text 9"/>
+          <p:cNvSpPr/>
+          <p:nvPr/>
+        </p:nvSpPr>
+        <p:spPr>
+          <a:xfrm>
+            <a:off x="5678424" y="2606040"/>
+            <a:ext cx="914400" cy="914400"/>
+          </a:xfrm>
+          <a:prstGeom prst="rect">
+            <a:avLst/>
+          </a:prstGeom>
+          <a:noFill/>
+          <a:ln/>
+        </p:spPr>
+        <p:txBody>
+          <a:bodyPr wrap="square" lIns="0" tIns="0" rIns="0" bIns="0" rtlCol="0" anchor="ctr"/>
+          <a:lstStyle/>
+          <a:p>
+            <a:pPr algn="ctr" indent="0" marL="0">
+              <a:buNone/>
+            </a:pPr>
+            <a:r>
+              <a:rPr lang="en-US" sz="2200" b="1" dirty="0">
+                <a:solidFill>
+                  <a:srgbClr val="FFFFFF"/>
+                </a:solidFill>
+                <a:latin typeface="Space Grotesk" pitchFamily="34" charset="0"/>
+                <a:ea typeface="Space Grotesk" pitchFamily="34" charset="-122"/>
+                <a:cs typeface="Space Grotesk" pitchFamily="34" charset="-120"/>
+              </a:rPr>
+              <a:t>AB</a:t>
+            </a:r>
+            <a:endParaRPr lang="en-US" sz="2200" dirty="0"/>
+          </a:p>
+        </p:txBody>
+      </p:sp>
+      <p:sp>
+        <p:nvSpPr>
+          <p:cNvPr id="12" name="Text 10"/>
+          <p:cNvSpPr/>
+          <p:nvPr/>
+        </p:nvSpPr>
+        <p:spPr>
+          <a:xfrm>
+            <a:off x="4581144" y="3749040"/>
+            <a:ext cx="3108960" cy="365760"/>
+          </a:xfrm>
+          <a:prstGeom prst="rect">
+            <a:avLst/>
+          </a:prstGeom>
+          <a:noFill/>
+          <a:ln/>
+        </p:spPr>
+        <p:txBody>
+          <a:bodyPr wrap="square" lIns="0" tIns="0" rIns="0" bIns="0" rtlCol="0" anchor="ctr"/>
+          <a:lstStyle/>
+          <a:p>
+            <a:pPr algn="ctr" indent="0" marL="0">
+              <a:buNone/>
+            </a:pPr>
+            <a:r>
+              <a:rPr lang="en-US" sz="1600" b="1" dirty="0">
+                <a:solidFill>
+                  <a:srgbClr val="0A0A0A"/>
+                </a:solidFill>
+                <a:latin typeface="Space Grotesk" pitchFamily="34" charset="0"/>
+                <a:ea typeface="Space Grotesk" pitchFamily="34" charset="-122"/>
+                <a:cs typeface="Space Grotesk" pitchFamily="34" charset="-120"/>
+              </a:rPr>
+              <a:t>Adrien Basso Blandin</a:t>
+            </a:r>
+            <a:endParaRPr lang="en-US" sz="1600" dirty="0"/>
+          </a:p>
+        </p:txBody>
+      </p:sp>
+      <p:sp>
+        <p:nvSpPr>
+          <p:cNvPr id="13" name="Text 11"/>
+          <p:cNvSpPr/>
+          <p:nvPr/>
+        </p:nvSpPr>
+        <p:spPr>
+          <a:xfrm>
+            <a:off x="4581144" y="4160520"/>
+            <a:ext cx="3108960" cy="365760"/>
+          </a:xfrm>
+          <a:prstGeom prst="rect">
+            <a:avLst/>
+          </a:prstGeom>
+          <a:noFill/>
+          <a:ln/>
+        </p:spPr>
+        <p:txBody>
+          <a:bodyPr wrap="square" lIns="0" tIns="0" rIns="0" bIns="0" rtlCol="0" anchor="ctr"/>
+          <a:lstStyle/>
+          <a:p>
+            <a:pPr algn="ctr" indent="0" marL="0">
+              <a:buNone/>
+            </a:pPr>
+            <a:r>
+              <a:rPr lang="en-US" sz="1150" dirty="0">
+                <a:solidFill>
+                  <a:srgbClr val="9296A6"/>
+                </a:solidFill>
+                <a:latin typeface="JetBrains Mono" pitchFamily="34" charset="0"/>
+                <a:ea typeface="JetBrains Mono" pitchFamily="34" charset="-122"/>
+                <a:cs typeface="JetBrains Mono" pitchFamily="34" charset="-120"/>
+              </a:rPr>
+              <a:t>Cohérence</a:t>
+            </a:r>
+            <a:endParaRPr lang="en-US" sz="1150" dirty="0"/>
+          </a:p>
+        </p:txBody>
+      </p:sp>
+      <p:sp>
+        <p:nvSpPr>
+          <p:cNvPr id="14" name="Shape 12"/>
+          <p:cNvSpPr/>
+          <p:nvPr/>
+        </p:nvSpPr>
+        <p:spPr>
+          <a:xfrm>
+            <a:off x="8156448" y="2194560"/>
+            <a:ext cx="3474720" cy="2926080"/>
+          </a:xfrm>
+          <a:prstGeom prst="roundRect">
+            <a:avLst>
+              <a:gd name="adj" fmla="val 3125"/>
+            </a:avLst>
+          </a:prstGeom>
+          <a:solidFill>
+            <a:srgbClr val="FFFFFF"/>
+          </a:solidFill>
+          <a:ln w="12700">
+            <a:solidFill>
+              <a:srgbClr val="E8E8EE"/>
+            </a:solidFill>
+            <a:prstDash val="solid"/>
+          </a:ln>
+          <a:effectLst>
+            <a:outerShdw sx="100000" sy="100000" kx="0" ky="0" algn="bl" rotWithShape="0" blurRad="114300" dist="38100" dir="5400000">
+              <a:srgbClr val="10122A">
+                <a:alpha val="12000"/>
+              </a:srgbClr>
+            </a:outerShdw>
+          </a:effectLst>
+        </p:spPr>
+      </p:sp>
+      <p:sp>
+        <p:nvSpPr>
+          <p:cNvPr id="15" name="Shape 13"/>
+          <p:cNvSpPr/>
+          <p:nvPr/>
+        </p:nvSpPr>
+        <p:spPr>
+          <a:xfrm>
+            <a:off x="9436608" y="2606040"/>
+            <a:ext cx="914400" cy="914400"/>
+          </a:xfrm>
+          <a:prstGeom prst="ellipse">
+            <a:avLst/>
+          </a:prstGeom>
+          <a:solidFill>
+            <a:srgbClr val="0066FF"/>
+          </a:solidFill>
+          <a:ln/>
+        </p:spPr>
+      </p:sp>
+      <p:sp>
+        <p:nvSpPr>
+          <p:cNvPr id="16" name="Text 14"/>
+          <p:cNvSpPr/>
+          <p:nvPr/>
+        </p:nvSpPr>
+        <p:spPr>
+          <a:xfrm>
+            <a:off x="9436608" y="2606040"/>
+            <a:ext cx="914400" cy="914400"/>
+          </a:xfrm>
+          <a:prstGeom prst="rect">
+            <a:avLst/>
+          </a:prstGeom>
+          <a:noFill/>
+          <a:ln/>
+        </p:spPr>
+        <p:txBody>
+          <a:bodyPr wrap="square" lIns="0" tIns="0" rIns="0" bIns="0" rtlCol="0" anchor="ctr"/>
+          <a:lstStyle/>
+          <a:p>
+            <a:pPr algn="ctr" indent="0" marL="0">
+              <a:buNone/>
+            </a:pPr>
+            <a:r>
+              <a:rPr lang="en-US" sz="2200" b="1" dirty="0">
+                <a:solidFill>
+                  <a:srgbClr val="FFFFFF"/>
+                </a:solidFill>
+                <a:latin typeface="Space Grotesk" pitchFamily="34" charset="0"/>
+                <a:ea typeface="Space Grotesk" pitchFamily="34" charset="-122"/>
+                <a:cs typeface="Space Grotesk" pitchFamily="34" charset="-120"/>
+              </a:rPr>
+              <a:t>AC</a:t>
+            </a:r>
+            <a:endParaRPr lang="en-US" sz="2200" dirty="0"/>
+          </a:p>
+        </p:txBody>
+      </p:sp>
+      <p:sp>
+        <p:nvSpPr>
+          <p:cNvPr id="17" name="Text 15"/>
+          <p:cNvSpPr/>
+          <p:nvPr/>
+        </p:nvSpPr>
+        <p:spPr>
+          <a:xfrm>
+            <a:off x="8339328" y="3749040"/>
+            <a:ext cx="3108960" cy="365760"/>
+          </a:xfrm>
+          <a:prstGeom prst="rect">
+            <a:avLst/>
+          </a:prstGeom>
+          <a:noFill/>
+          <a:ln/>
+        </p:spPr>
+        <p:txBody>
+          <a:bodyPr wrap="square" lIns="0" tIns="0" rIns="0" bIns="0" rtlCol="0" anchor="ctr"/>
+          <a:lstStyle/>
+          <a:p>
+            <a:pPr algn="ctr" indent="0" marL="0">
+              <a:buNone/>
+            </a:pPr>
+            <a:r>
+              <a:rPr lang="en-US" sz="1600" b="1" dirty="0">
+                <a:solidFill>
+                  <a:srgbClr val="0A0A0A"/>
+                </a:solidFill>
+                <a:latin typeface="Space Grotesk" pitchFamily="34" charset="0"/>
+                <a:ea typeface="Space Grotesk" pitchFamily="34" charset="-122"/>
+                <a:cs typeface="Space Grotesk" pitchFamily="34" charset="-120"/>
+              </a:rPr>
+              <a:t>Adrien Charles</a:t>
+            </a:r>
+            <a:endParaRPr lang="en-US" sz="1600" dirty="0"/>
+          </a:p>
+        </p:txBody>
+      </p:sp>
+      <p:sp>
+        <p:nvSpPr>
+          <p:cNvPr id="18" name="Text 16"/>
+          <p:cNvSpPr/>
+          <p:nvPr/>
+        </p:nvSpPr>
+        <p:spPr>
+          <a:xfrm>
+            <a:off x="8339328" y="4160520"/>
+            <a:ext cx="3108960" cy="365760"/>
+          </a:xfrm>
+          <a:prstGeom prst="rect">
+            <a:avLst/>
+          </a:prstGeom>
+          <a:noFill/>
+          <a:ln/>
+        </p:spPr>
+        <p:txBody>
+          <a:bodyPr wrap="square" lIns="0" tIns="0" rIns="0" bIns="0" rtlCol="0" anchor="ctr"/>
+          <a:lstStyle/>
+          <a:p>
+            <a:pPr algn="ctr" indent="0" marL="0">
+              <a:buNone/>
+            </a:pPr>
+            <a:r>
+              <a:rPr lang="en-US" sz="1150" dirty="0">
+                <a:solidFill>
+                  <a:srgbClr val="9296A6"/>
+                </a:solidFill>
+                <a:latin typeface="JetBrains Mono" pitchFamily="34" charset="0"/>
+                <a:ea typeface="JetBrains Mono" pitchFamily="34" charset="-122"/>
+                <a:cs typeface="JetBrains Mono" pitchFamily="34" charset="-120"/>
+              </a:rPr>
+              <a:t>Produit</a:t>
+            </a:r>
+            <a:endParaRPr lang="en-US" sz="1150" dirty="0"/>
+          </a:p>
+        </p:txBody>
+      </p:sp>
+      <p:sp>
+        <p:nvSpPr>
+          <p:cNvPr id="19" name="Text 17"/>
+          <p:cNvSpPr/>
+          <p:nvPr/>
+        </p:nvSpPr>
+        <p:spPr>
+          <a:xfrm>
+            <a:off x="11185855" y="6400800"/>
+            <a:ext cx="548640" cy="274320"/>
+          </a:xfrm>
+          <a:prstGeom prst="rect">
+            <a:avLst/>
+          </a:prstGeom>
+          <a:noFill/>
+          <a:ln/>
+        </p:spPr>
+        <p:txBody>
+          <a:bodyPr wrap="square" lIns="0" tIns="0" rIns="0" bIns="0" rtlCol="0" anchor="ctr"/>
+          <a:lstStyle/>
+          <a:p>
+            <a:pPr algn="r" indent="0" marL="0">
+              <a:buNone/>
+            </a:pPr>
+            <a:r>
+              <a:rPr lang="en-US" sz="1000" dirty="0">
+                <a:solidFill>
+                  <a:srgbClr val="9296A6"/>
+                </a:solidFill>
+                <a:latin typeface="JetBrains Mono" pitchFamily="34" charset="0"/>
+                <a:ea typeface="JetBrains Mono" pitchFamily="34" charset="-122"/>
+                <a:cs typeface="JetBrains Mono" pitchFamily="34" charset="-120"/>
+              </a:rPr>
+              <a:t>13</a:t>
+            </a:r>
+            <a:endParaRPr lang="en-US" sz="1000" dirty="0"/>
+          </a:p>
+        </p:txBody>
+      </p:sp>
+    </p:spTree>
+  </p:cSld>
+  <p:clrMapOvr>
+    <a:masterClrMapping/>
+  </p:clrMapOvr>
+</p:sld>
+</file>
+
+<file path=ppt/slides/slide14.xml><?xml version="1.0" encoding="utf-8"?>
+<p:sld xmlns:a="http://schemas.openxmlformats.org/drawingml/2006/main" xmlns:r="http://schemas.openxmlformats.org/officeDocument/2006/relationships" xmlns:p="http://schemas.openxmlformats.org/presentationml/2006/main">
+  <p:cSld name="Slide 14">
     <p:bg>
       <p:bgPr>
         <a:solidFill>

</xml_diff>